<commit_message>
Add AX success conditions and hybrid model slide to FDE deck
Co-Authored-By: Claude Opus 5.5 <noreply@anthropic.com>
Claude-Session: https://claude.ai/code/session_014bmYQ2fMPYk9mSnunBW5W4
</commit_message>
<xml_diff>
--- a/27_중점과제_FDE_대내사업확대_v2.pptx
+++ b/27_중점과제_FDE_대내사업확대_v2.pptx
@@ -6,9 +6,10 @@
   </p:sldMasterIdLst>
   <p:sldIdLst>
     <p:sldId id="256" r:id="rId2"/>
+    <p:sldId id="257" r:id="rId3"/>
   </p:sldIdLst>
   <p:notesMasterIdLst>
-    <p:notesMasterId r:id="rId3"/>
+    <p:notesMasterId r:id="rId4"/>
   </p:notesMasterIdLst>
   <p:sldSz cx="12192000" cy="6858000"/>
   <p:notesSz cx="6858000" cy="12192000"/>
@@ -526,6 +527,94 @@
             <a:fld id="{F7021451-1387-4CA6-816F-3879F97B5CBC}" type="slidenum">
               <a:rPr lang="en-US"/>
               <a:t>1</a:t>
+            </a:fld>
+            <a:endParaRPr lang="en-US"/>
+          </a:p>
+        </p:txBody>
+      </p:sp>
+    </p:spTree>
+    <p:extLst>
+      <p:ext uri="{BB962C8B-B14F-4D97-AF65-F5344CB8AC3E}">
+        <p14:creationId xmlns:p14="http://schemas.microsoft.com/office/powerpoint/2010/main" val="1024086991"/>
+      </p:ext>
+    </p:extLst>
+  </p:cSld>
+  <p:clrMapOvr>
+    <a:masterClrMapping/>
+  </p:clrMapOvr>
+</p:notes>
+</file>
+
+<file path=ppt/notesSlides/notesSlide2.xml><?xml version="1.0" encoding="utf-8"?>
+<p:notes xmlns:a="http://schemas.openxmlformats.org/drawingml/2006/main" xmlns:r="http://schemas.openxmlformats.org/officeDocument/2006/relationships" xmlns:p="http://schemas.openxmlformats.org/presentationml/2006/main">
+  <p:cSld>
+    <p:spTree>
+      <p:nvGrpSpPr>
+        <p:cNvPr id="1" name=""/>
+        <p:cNvGrpSpPr/>
+        <p:nvPr/>
+      </p:nvGrpSpPr>
+      <p:grpSpPr>
+        <a:xfrm>
+          <a:off x="0" y="0"/>
+          <a:ext cx="0" cy="0"/>
+          <a:chOff x="0" y="0"/>
+          <a:chExt cx="0" cy="0"/>
+        </a:xfrm>
+      </p:grpSpPr>
+      <p:sp>
+        <p:nvSpPr>
+          <p:cNvPr id="2" name="Slide Image Placeholder 1"/>
+          <p:cNvSpPr>
+            <a:spLocks noGrp="1" noRot="1" noChangeAspect="1"/>
+          </p:cNvSpPr>
+          <p:nvPr>
+            <p:ph type="sldImg"/>
+          </p:nvPr>
+        </p:nvSpPr>
+        <p:spPr/>
+      </p:sp>
+      <p:sp>
+        <p:nvSpPr>
+          <p:cNvPr id="3" name="Notes Placeholder 2"/>
+          <p:cNvSpPr>
+            <a:spLocks noGrp="1"/>
+          </p:cNvSpPr>
+          <p:nvPr>
+            <p:ph type="body" idx="1"/>
+          </p:nvPr>
+        </p:nvSpPr>
+        <p:spPr/>
+        <p:txBody>
+          <a:bodyPr/>
+          <a:lstStyle/>
+          <a:p>
+            <a:r>
+              <a:rPr lang="en-US" dirty="0"/>
+              <a:t>주요 컨설팅사 공통 성공조건 5가지 대비 우리 FDE 대응과 보완점. 6단계 추진방안 단계별 담당, 대기업형 혼합 모델(실행·플랫폼 / 경영·조직 / 리스크·규제)을 그룹 내 역량으로 매핑.</a:t>
+            </a:r>
+            <a:endParaRPr lang="en-US" dirty="0"/>
+          </a:p>
+        </p:txBody>
+      </p:sp>
+      <p:sp>
+        <p:nvSpPr>
+          <p:cNvPr id="4" name="Slide Number Placeholder 3"/>
+          <p:cNvSpPr>
+            <a:spLocks noGrp="1"/>
+          </p:cNvSpPr>
+          <p:nvPr>
+            <p:ph type="sldNum" sz="quarter" idx="10"/>
+          </p:nvPr>
+        </p:nvSpPr>
+        <p:spPr/>
+        <p:txBody>
+          <a:bodyPr/>
+          <a:lstStyle/>
+          <a:p>
+            <a:fld id="{F7021451-1387-4CA6-816F-3879F97B5CBC}" type="slidenum">
+              <a:rPr lang="en-US"/>
+              <a:t>2</a:t>
             </a:fld>
             <a:endParaRPr lang="en-US"/>
           </a:p>
@@ -4155,6 +4244,3647 @@
 </p:sld>
 </file>
 
+<file path=ppt/slides/slide2.xml><?xml version="1.0" encoding="utf-8"?>
+<p:sld xmlns:a="http://schemas.openxmlformats.org/drawingml/2006/main" xmlns:r="http://schemas.openxmlformats.org/officeDocument/2006/relationships" xmlns:p="http://schemas.openxmlformats.org/presentationml/2006/main">
+  <p:cSld name="Slide 2">
+    <p:spTree>
+      <p:nvGrpSpPr>
+        <p:cNvPr id="1" name=""/>
+        <p:cNvGrpSpPr/>
+        <p:nvPr/>
+      </p:nvGrpSpPr>
+      <p:grpSpPr>
+        <a:xfrm>
+          <a:off x="0" y="0"/>
+          <a:ext cx="0" cy="0"/>
+          <a:chOff x="0" y="0"/>
+          <a:chExt cx="0" cy="0"/>
+        </a:xfrm>
+      </p:grpSpPr>
+      <p:sp>
+        <p:nvSpPr>
+          <p:cNvPr id="2" name="Text 1"/>
+          <p:cNvSpPr/>
+          <p:nvPr>
+            <p:ph idx="101" type="title" hasCustomPrompt="1"/>
+          </p:nvPr>
+        </p:nvSpPr>
+        <p:spPr>
+          <a:xfrm>
+            <a:off x="365760" y="228600"/>
+            <a:ext cx="11430000" cy="640080"/>
+          </a:xfrm>
+          <a:prstGeom prst="rect">
+            <a:avLst/>
+          </a:prstGeom>
+          <a:noFill/>
+          <a:ln/>
+        </p:spPr>
+        <p:txBody>
+          <a:bodyPr wrap="square" lIns="0" tIns="0" rIns="0" bIns="0" rtlCol="0" anchor="ctr"/>
+          <a:lstStyle/>
+          <a:p>
+            <a:pPr algn="l" indent="0" marL="0">
+              <a:buNone/>
+            </a:pPr>
+            <a:r>
+              <a:rPr lang="en-US" sz="2400" b="1" dirty="0">
+                <a:solidFill>
+                  <a:schemeClr val="tx1"/>
+                </a:solidFill>
+              </a:rPr>
+              <a:t>'27년 중점추진과제  &gt;  </a:t>
+            </a:r>
+            <a:pPr algn="l" indent="0" marL="0">
+              <a:buNone/>
+            </a:pPr>
+            <a:r>
+              <a:rPr lang="en-US" sz="2000" b="1" dirty="0">
+                <a:solidFill>
+                  <a:schemeClr val="accent1"/>
+                </a:solidFill>
+              </a:rPr>
+              <a:t>③ FDE를 통한 대내 사업 확대</a:t>
+            </a:r>
+            <a:endParaRPr lang="en-US" sz="2600" dirty="0"/>
+          </a:p>
+        </p:txBody>
+      </p:sp>
+      <p:sp>
+        <p:nvSpPr>
+          <p:cNvPr id="3" name="Text 1"/>
+          <p:cNvSpPr txBox="1"/>
+          <p:nvPr/>
+        </p:nvSpPr>
+        <p:spPr>
+          <a:xfrm>
+            <a:off x="365760" y="1024128"/>
+            <a:ext cx="1828800" cy="420624"/>
+          </a:xfrm>
+          <a:prstGeom prst="rect">
+            <a:avLst/>
+          </a:prstGeom>
+          <a:noFill/>
+          <a:ln/>
+        </p:spPr>
+        <p:txBody>
+          <a:bodyPr wrap="square" lIns="0" tIns="0" rIns="0" bIns="0" rtlCol="0" anchor="ctr"/>
+          <a:lstStyle/>
+          <a:p>
+            <a:pPr indent="0" marL="0">
+              <a:buNone/>
+            </a:pPr>
+            <a:r>
+              <a:rPr lang="en-US" sz="1300" b="1" dirty="0">
+                <a:solidFill>
+                  <a:schemeClr val="tx1"/>
+                </a:solidFill>
+              </a:rPr>
+              <a:t>과제 수행 방향 요약</a:t>
+            </a:r>
+            <a:endParaRPr lang="en-US" sz="1300" dirty="0"/>
+          </a:p>
+        </p:txBody>
+      </p:sp>
+      <p:sp>
+        <p:nvSpPr>
+          <p:cNvPr id="4" name="방향 요약"/>
+          <p:cNvSpPr txBox="1"/>
+          <p:nvPr/>
+        </p:nvSpPr>
+        <p:spPr>
+          <a:xfrm>
+            <a:off x="2194560" y="1024128"/>
+            <a:ext cx="9628632" cy="420624"/>
+          </a:xfrm>
+          <a:prstGeom prst="rect">
+            <a:avLst/>
+          </a:prstGeom>
+          <a:solidFill>
+            <a:schemeClr val="accent4"/>
+          </a:solidFill>
+          <a:ln/>
+        </p:spPr>
+        <p:txBody>
+          <a:bodyPr wrap="square" lIns="0" tIns="101600" rIns="101600" bIns="0" rtlCol="0" anchor="ctr"/>
+          <a:lstStyle/>
+          <a:p>
+            <a:pPr indent="0" marL="0">
+              <a:buNone/>
+            </a:pPr>
+            <a:r>
+              <a:rPr lang="en-US" sz="1150" b="1" dirty="0">
+                <a:solidFill>
+                  <a:schemeClr val="tx2"/>
+                </a:solidFill>
+              </a:rPr>
+              <a:t>주요 컨설팅사가 제시한 AX 성공조건 5가지를 FDE 공동 TF(AX·Biz + 엔지니어)로 충족 → 그룹 내부 역량으로 혼합형 AX 모델 구현</a:t>
+            </a:r>
+            <a:endParaRPr lang="en-US" sz="1150" dirty="0"/>
+          </a:p>
+        </p:txBody>
+      </p:sp>
+      <p:sp>
+        <p:nvSpPr>
+          <p:cNvPr id="5" name="Text 3"/>
+          <p:cNvSpPr txBox="1"/>
+          <p:nvPr/>
+        </p:nvSpPr>
+        <p:spPr>
+          <a:xfrm>
+            <a:off x="365760" y="1591056"/>
+            <a:ext cx="5532120" cy="329184"/>
+          </a:xfrm>
+          <a:prstGeom prst="rect">
+            <a:avLst/>
+          </a:prstGeom>
+          <a:noFill/>
+          <a:ln/>
+        </p:spPr>
+        <p:txBody>
+          <a:bodyPr wrap="square" lIns="0" tIns="0" rIns="0" bIns="0" rtlCol="0" anchor="ctr"/>
+          <a:lstStyle/>
+          <a:p>
+            <a:pPr algn="ctr" indent="0" marL="0">
+              <a:buNone/>
+            </a:pPr>
+            <a:r>
+              <a:rPr lang="en-US" sz="1500" b="1" dirty="0">
+                <a:solidFill>
+                  <a:schemeClr val="tx1"/>
+                </a:solidFill>
+              </a:rPr>
+              <a:t>AX 성공조건과 FDE 대응</a:t>
+            </a:r>
+            <a:endParaRPr lang="en-US" sz="1500" dirty="0"/>
+          </a:p>
+        </p:txBody>
+      </p:sp>
+      <p:sp>
+        <p:nvSpPr>
+          <p:cNvPr id="6" name="구역선 AX 성공조건과 FDE 대응"/>
+          <p:cNvSpPr/>
+          <p:nvPr/>
+        </p:nvSpPr>
+        <p:spPr>
+          <a:xfrm>
+            <a:off x="365760" y="1938528"/>
+            <a:ext cx="5532120" cy="0"/>
+          </a:xfrm>
+          <a:prstGeom prst="line">
+            <a:avLst/>
+          </a:prstGeom>
+          <a:noFill/>
+          <a:ln w="31750">
+            <a:solidFill>
+              <a:srgbClr val="8A94A6"/>
+            </a:solidFill>
+            <a:prstDash val="solid"/>
+          </a:ln>
+        </p:spPr>
+      </p:sp>
+      <p:sp>
+        <p:nvSpPr>
+          <p:cNvPr id="7" name="Text 5"/>
+          <p:cNvSpPr txBox="1"/>
+          <p:nvPr/>
+        </p:nvSpPr>
+        <p:spPr>
+          <a:xfrm>
+            <a:off x="6291072" y="1591056"/>
+            <a:ext cx="5532120" cy="329184"/>
+          </a:xfrm>
+          <a:prstGeom prst="rect">
+            <a:avLst/>
+          </a:prstGeom>
+          <a:noFill/>
+          <a:ln/>
+        </p:spPr>
+        <p:txBody>
+          <a:bodyPr wrap="square" lIns="0" tIns="0" rIns="0" bIns="0" rtlCol="0" anchor="ctr"/>
+          <a:lstStyle/>
+          <a:p>
+            <a:pPr algn="ctr" indent="0" marL="0">
+              <a:buNone/>
+            </a:pPr>
+            <a:r>
+              <a:rPr lang="en-US" sz="1500" b="1" dirty="0">
+                <a:solidFill>
+                  <a:schemeClr val="tx1"/>
+                </a:solidFill>
+              </a:rPr>
+              <a:t>혼합형 AX 추진모델 수행 역량</a:t>
+            </a:r>
+            <a:endParaRPr lang="en-US" sz="1500" dirty="0"/>
+          </a:p>
+        </p:txBody>
+      </p:sp>
+      <p:sp>
+        <p:nvSpPr>
+          <p:cNvPr id="8" name="구역선 혼합형 AX 추진모델 수행 역량"/>
+          <p:cNvSpPr/>
+          <p:nvPr/>
+        </p:nvSpPr>
+        <p:spPr>
+          <a:xfrm>
+            <a:off x="6291072" y="1938528"/>
+            <a:ext cx="5532120" cy="0"/>
+          </a:xfrm>
+          <a:prstGeom prst="line">
+            <a:avLst/>
+          </a:prstGeom>
+          <a:noFill/>
+          <a:ln w="31750">
+            <a:solidFill>
+              <a:srgbClr val="8A94A6"/>
+            </a:solidFill>
+            <a:prstDash val="solid"/>
+          </a:ln>
+        </p:spPr>
+      </p:sp>
+      <p:sp>
+        <p:nvSpPr>
+          <p:cNvPr id="9" name="Text 7"/>
+          <p:cNvSpPr txBox="1"/>
+          <p:nvPr/>
+        </p:nvSpPr>
+        <p:spPr>
+          <a:xfrm>
+            <a:off x="411480" y="2029968"/>
+            <a:ext cx="5532120" cy="256032"/>
+          </a:xfrm>
+          <a:prstGeom prst="rect">
+            <a:avLst/>
+          </a:prstGeom>
+          <a:noFill/>
+          <a:ln/>
+        </p:spPr>
+        <p:txBody>
+          <a:bodyPr wrap="square" lIns="0" tIns="0" rIns="0" bIns="0" rtlCol="0" anchor="ctr"/>
+          <a:lstStyle/>
+          <a:p>
+            <a:pPr indent="0" marL="0">
+              <a:buNone/>
+            </a:pPr>
+            <a:r>
+              <a:rPr lang="en-US" sz="1050" b="1" dirty="0">
+                <a:solidFill>
+                  <a:schemeClr val="accent5"/>
+                </a:solidFill>
+              </a:rPr>
+              <a:t>※ 주요 컨설팅사 제안 종합 : AX 추진 시 가장 중요한 성공조건</a:t>
+            </a:r>
+            <a:endParaRPr lang="en-US" sz="1050" dirty="0"/>
+          </a:p>
+        </p:txBody>
+      </p:sp>
+      <p:graphicFrame>
+        <p:nvGraphicFramePr>
+          <p:cNvPr id="3" name="성공조건 대응 표"/>
+          <p:cNvGraphicFramePr>
+            <a:graphicFrameLocks noGrp="1"/>
+          </p:cNvGraphicFramePr>
+          <p:nvPr>
+            <p:extLst>
+              <p:ext uri="{D42A27DB-BD31-4B8C-83A1-F6EECF244321}">
+                <p14:modId xmlns:p14="http://schemas.microsoft.com/office/powerpoint/2010/main" val="1579011935"/>
+              </p:ext>
+            </p:extLst>
+          </p:nvPr>
+        </p:nvGraphicFramePr>
+        <p:xfrm>
+          <a:off x="365760" y="2331720"/>
+          <a:ext cx="5532120" cy="914400"/>
+        </p:xfrm>
+        <a:graphic>
+          <a:graphicData uri="http://schemas.openxmlformats.org/drawingml/2006/table">
+            <a:tbl>
+              <a:tblPr/>
+              <a:tblGrid>
+                <a:gridCol w="1783080"/>
+                <a:gridCol w="2606040"/>
+                <a:gridCol w="685800"/>
+                <a:gridCol w="457200"/>
+              </a:tblGrid>
+              <a:tr h="237744">
+                <a:tc>
+                  <a:txBody>
+                    <a:bodyPr/>
+                    <a:lstStyle/>
+                    <a:p>
+                      <a:pPr algn="ctr" indent="0" marL="0">
+                        <a:buNone/>
+                      </a:pPr>
+                      <a:r>
+                        <a:rPr lang="en-US" sz="950" b="1" dirty="0">
+                          <a:solidFill>
+                            <a:srgbClr val="1F2329"/>
+                          </a:solidFill>
+                          <a:latin typeface="맑은 고딕" pitchFamily="34" charset="0"/>
+                          <a:ea typeface="맑은 고딕" pitchFamily="34" charset="-122"/>
+                          <a:cs typeface="맑은 고딕" pitchFamily="34" charset="-120"/>
+                        </a:rPr>
+                        <a:t>성공조건</a:t>
+                      </a:r>
+                      <a:endParaRPr lang="en-US" sz="950" dirty="0">
+                        <a:latin typeface="맑은 고딕" charset="0"/>
+                        <a:ea typeface="맑은 고딕" charset="0"/>
+                        <a:cs typeface="맑은 고딕" charset="0"/>
+                      </a:endParaRPr>
+                    </a:p>
+                  </a:txBody>
+                  <a:tcPr marL="45720" marR="45720" marT="18288" marB="18288" anchor="ctr">
+                    <a:lnL w="9525" cap="flat" cmpd="sng" algn="ctr">
+                      <a:solidFill>
+                        <a:srgbClr val="BFC5CF"/>
+                      </a:solidFill>
+                      <a:prstDash val="solid"/>
+                      <a:round/>
+                      <a:headEnd type="none" w="med" len="med"/>
+                      <a:tailEnd type="none" w="med" len="med"/>
+                    </a:lnL>
+                    <a:lnR w="9525" cap="flat" cmpd="sng" algn="ctr">
+                      <a:solidFill>
+                        <a:srgbClr val="BFC5CF"/>
+                      </a:solidFill>
+                      <a:prstDash val="solid"/>
+                      <a:round/>
+                      <a:headEnd type="none" w="med" len="med"/>
+                      <a:tailEnd type="none" w="med" len="med"/>
+                    </a:lnR>
+                    <a:lnT w="9525" cap="flat" cmpd="sng" algn="ctr">
+                      <a:solidFill>
+                        <a:srgbClr val="BFC5CF"/>
+                      </a:solidFill>
+                      <a:prstDash val="solid"/>
+                      <a:round/>
+                      <a:headEnd type="none" w="med" len="med"/>
+                      <a:tailEnd type="none" w="med" len="med"/>
+                    </a:lnT>
+                    <a:lnB w="9525" cap="flat" cmpd="sng" algn="ctr">
+                      <a:solidFill>
+                        <a:srgbClr val="BFC5CF"/>
+                      </a:solidFill>
+                      <a:prstDash val="solid"/>
+                      <a:round/>
+                      <a:headEnd type="none" w="med" len="med"/>
+                      <a:tailEnd type="none" w="med" len="med"/>
+                    </a:lnB>
+                    <a:solidFill>
+                      <a:srgbClr val="D9DDE3"/>
+                    </a:solidFill>
+                  </a:tcPr>
+                </a:tc>
+                <a:tc>
+                  <a:txBody>
+                    <a:bodyPr/>
+                    <a:lstStyle/>
+                    <a:p>
+                      <a:pPr algn="ctr" indent="0" marL="0">
+                        <a:buNone/>
+                      </a:pPr>
+                      <a:r>
+                        <a:rPr lang="en-US" sz="950" b="1" dirty="0">
+                          <a:solidFill>
+                            <a:srgbClr val="1F2329"/>
+                          </a:solidFill>
+                          <a:latin typeface="맑은 고딕" pitchFamily="34" charset="0"/>
+                          <a:ea typeface="맑은 고딕" pitchFamily="34" charset="-122"/>
+                          <a:cs typeface="맑은 고딕" pitchFamily="34" charset="-120"/>
+                        </a:rPr>
+                        <a:t>우리 FDE 대응 (근거)</a:t>
+                      </a:r>
+                      <a:endParaRPr lang="en-US" sz="950" dirty="0">
+                        <a:latin typeface="맑은 고딕" charset="0"/>
+                        <a:ea typeface="맑은 고딕" charset="0"/>
+                        <a:cs typeface="맑은 고딕" charset="0"/>
+                      </a:endParaRPr>
+                    </a:p>
+                  </a:txBody>
+                  <a:tcPr marL="45720" marR="45720" marT="18288" marB="18288" anchor="ctr">
+                    <a:lnL w="9525" cap="flat" cmpd="sng" algn="ctr">
+                      <a:solidFill>
+                        <a:srgbClr val="BFC5CF"/>
+                      </a:solidFill>
+                      <a:prstDash val="solid"/>
+                      <a:round/>
+                      <a:headEnd type="none" w="med" len="med"/>
+                      <a:tailEnd type="none" w="med" len="med"/>
+                    </a:lnL>
+                    <a:lnR w="9525" cap="flat" cmpd="sng" algn="ctr">
+                      <a:solidFill>
+                        <a:srgbClr val="BFC5CF"/>
+                      </a:solidFill>
+                      <a:prstDash val="solid"/>
+                      <a:round/>
+                      <a:headEnd type="none" w="med" len="med"/>
+                      <a:tailEnd type="none" w="med" len="med"/>
+                    </a:lnR>
+                    <a:lnT w="9525" cap="flat" cmpd="sng" algn="ctr">
+                      <a:solidFill>
+                        <a:srgbClr val="BFC5CF"/>
+                      </a:solidFill>
+                      <a:prstDash val="solid"/>
+                      <a:round/>
+                      <a:headEnd type="none" w="med" len="med"/>
+                      <a:tailEnd type="none" w="med" len="med"/>
+                    </a:lnT>
+                    <a:lnB w="9525" cap="flat" cmpd="sng" algn="ctr">
+                      <a:solidFill>
+                        <a:srgbClr val="BFC5CF"/>
+                      </a:solidFill>
+                      <a:prstDash val="solid"/>
+                      <a:round/>
+                      <a:headEnd type="none" w="med" len="med"/>
+                      <a:tailEnd type="none" w="med" len="med"/>
+                    </a:lnB>
+                    <a:solidFill>
+                      <a:srgbClr val="D9DDE3"/>
+                    </a:solidFill>
+                  </a:tcPr>
+                </a:tc>
+                <a:tc>
+                  <a:txBody>
+                    <a:bodyPr/>
+                    <a:lstStyle/>
+                    <a:p>
+                      <a:pPr algn="ctr" indent="0" marL="0">
+                        <a:buNone/>
+                      </a:pPr>
+                      <a:r>
+                        <a:rPr lang="en-US" sz="950" b="1" dirty="0">
+                          <a:solidFill>
+                            <a:srgbClr val="1F2329"/>
+                          </a:solidFill>
+                          <a:latin typeface="맑은 고딕" pitchFamily="34" charset="0"/>
+                          <a:ea typeface="맑은 고딕" pitchFamily="34" charset="-122"/>
+                          <a:cs typeface="맑은 고딕" pitchFamily="34" charset="-120"/>
+                        </a:rPr>
+                        <a:t>담당</a:t>
+                      </a:r>
+                      <a:endParaRPr lang="en-US" sz="950" dirty="0">
+                        <a:latin typeface="맑은 고딕" charset="0"/>
+                        <a:ea typeface="맑은 고딕" charset="0"/>
+                        <a:cs typeface="맑은 고딕" charset="0"/>
+                      </a:endParaRPr>
+                    </a:p>
+                  </a:txBody>
+                  <a:tcPr marL="45720" marR="45720" marT="18288" marB="18288" anchor="ctr">
+                    <a:lnL w="9525" cap="flat" cmpd="sng" algn="ctr">
+                      <a:solidFill>
+                        <a:srgbClr val="BFC5CF"/>
+                      </a:solidFill>
+                      <a:prstDash val="solid"/>
+                      <a:round/>
+                      <a:headEnd type="none" w="med" len="med"/>
+                      <a:tailEnd type="none" w="med" len="med"/>
+                    </a:lnL>
+                    <a:lnR w="9525" cap="flat" cmpd="sng" algn="ctr">
+                      <a:solidFill>
+                        <a:srgbClr val="BFC5CF"/>
+                      </a:solidFill>
+                      <a:prstDash val="solid"/>
+                      <a:round/>
+                      <a:headEnd type="none" w="med" len="med"/>
+                      <a:tailEnd type="none" w="med" len="med"/>
+                    </a:lnR>
+                    <a:lnT w="9525" cap="flat" cmpd="sng" algn="ctr">
+                      <a:solidFill>
+                        <a:srgbClr val="BFC5CF"/>
+                      </a:solidFill>
+                      <a:prstDash val="solid"/>
+                      <a:round/>
+                      <a:headEnd type="none" w="med" len="med"/>
+                      <a:tailEnd type="none" w="med" len="med"/>
+                    </a:lnT>
+                    <a:lnB w="9525" cap="flat" cmpd="sng" algn="ctr">
+                      <a:solidFill>
+                        <a:srgbClr val="BFC5CF"/>
+                      </a:solidFill>
+                      <a:prstDash val="solid"/>
+                      <a:round/>
+                      <a:headEnd type="none" w="med" len="med"/>
+                      <a:tailEnd type="none" w="med" len="med"/>
+                    </a:lnB>
+                    <a:solidFill>
+                      <a:srgbClr val="D9DDE3"/>
+                    </a:solidFill>
+                  </a:tcPr>
+                </a:tc>
+                <a:tc>
+                  <a:txBody>
+                    <a:bodyPr/>
+                    <a:lstStyle/>
+                    <a:p>
+                      <a:pPr algn="ctr" indent="0" marL="0">
+                        <a:buNone/>
+                      </a:pPr>
+                      <a:r>
+                        <a:rPr lang="en-US" sz="950" b="1" dirty="0">
+                          <a:solidFill>
+                            <a:srgbClr val="1F2329"/>
+                          </a:solidFill>
+                          <a:latin typeface="맑은 고딕" pitchFamily="34" charset="0"/>
+                          <a:ea typeface="맑은 고딕" pitchFamily="34" charset="-122"/>
+                          <a:cs typeface="맑은 고딕" pitchFamily="34" charset="-120"/>
+                        </a:rPr>
+                        <a:t>수준</a:t>
+                      </a:r>
+                      <a:endParaRPr lang="en-US" sz="950" dirty="0">
+                        <a:latin typeface="맑은 고딕" charset="0"/>
+                        <a:ea typeface="맑은 고딕" charset="0"/>
+                        <a:cs typeface="맑은 고딕" charset="0"/>
+                      </a:endParaRPr>
+                    </a:p>
+                  </a:txBody>
+                  <a:tcPr marL="45720" marR="45720" marT="18288" marB="18288" anchor="ctr">
+                    <a:lnL w="9525" cap="flat" cmpd="sng" algn="ctr">
+                      <a:solidFill>
+                        <a:srgbClr val="BFC5CF"/>
+                      </a:solidFill>
+                      <a:prstDash val="solid"/>
+                      <a:round/>
+                      <a:headEnd type="none" w="med" len="med"/>
+                      <a:tailEnd type="none" w="med" len="med"/>
+                    </a:lnL>
+                    <a:lnR w="9525" cap="flat" cmpd="sng" algn="ctr">
+                      <a:solidFill>
+                        <a:srgbClr val="BFC5CF"/>
+                      </a:solidFill>
+                      <a:prstDash val="solid"/>
+                      <a:round/>
+                      <a:headEnd type="none" w="med" len="med"/>
+                      <a:tailEnd type="none" w="med" len="med"/>
+                    </a:lnR>
+                    <a:lnT w="9525" cap="flat" cmpd="sng" algn="ctr">
+                      <a:solidFill>
+                        <a:srgbClr val="BFC5CF"/>
+                      </a:solidFill>
+                      <a:prstDash val="solid"/>
+                      <a:round/>
+                      <a:headEnd type="none" w="med" len="med"/>
+                      <a:tailEnd type="none" w="med" len="med"/>
+                    </a:lnT>
+                    <a:lnB w="9525" cap="flat" cmpd="sng" algn="ctr">
+                      <a:solidFill>
+                        <a:srgbClr val="BFC5CF"/>
+                      </a:solidFill>
+                      <a:prstDash val="solid"/>
+                      <a:round/>
+                      <a:headEnd type="none" w="med" len="med"/>
+                      <a:tailEnd type="none" w="med" len="med"/>
+                    </a:lnB>
+                    <a:solidFill>
+                      <a:srgbClr val="D9DDE3"/>
+                    </a:solidFill>
+                  </a:tcPr>
+                </a:tc>
+              </a:tr>
+              <a:tr h="512064">
+                <a:tc>
+                  <a:txBody>
+                    <a:bodyPr/>
+                    <a:lstStyle/>
+                    <a:p>
+                      <a:pPr indent="0" marL="0">
+                        <a:buNone/>
+                      </a:pPr>
+                      <a:r>
+                        <a:rPr lang="en-US" sz="950" b="1" dirty="0">
+                          <a:solidFill>
+                            <a:srgbClr val="2F3E55"/>
+                          </a:solidFill>
+                          <a:latin typeface="맑은 고딕" pitchFamily="34" charset="0"/>
+                          <a:ea typeface="맑은 고딕" pitchFamily="34" charset="-122"/>
+                          <a:cs typeface="맑은 고딕" pitchFamily="34" charset="-120"/>
+                        </a:rPr>
+                        <a:t>1. 사업성과에서 출발</a:t>
+                      </a:r>
+                      <a:endParaRPr lang="en-US" sz="900" dirty="0">
+                        <a:latin typeface="맑은 고딕" charset="0"/>
+                        <a:ea typeface="맑은 고딕" charset="0"/>
+                        <a:cs typeface="맑은 고딕" charset="0"/>
+                      </a:endParaRPr>
+                    </a:p>
+                    <a:p>
+                      <a:pPr indent="0" marL="0">
+                        <a:buNone/>
+                      </a:pPr>
+                      <a:r>
+                        <a:rPr lang="en-US" sz="800" dirty="0">
+                          <a:solidFill>
+                            <a:srgbClr val="5B6B82"/>
+                          </a:solidFill>
+                          <a:latin typeface="맑은 고딕" pitchFamily="34" charset="0"/>
+                          <a:ea typeface="맑은 고딕" pitchFamily="34" charset="-122"/>
+                          <a:cs typeface="맑은 고딕" pitchFamily="34" charset="-120"/>
+                        </a:rPr>
+                        <a:t>모델·플랫폼 우선 시 PoC만 증가</a:t>
+                      </a:r>
+                      <a:endParaRPr lang="en-US" sz="900" dirty="0">
+                        <a:latin typeface="맑은 고딕" charset="0"/>
+                        <a:ea typeface="맑은 고딕" charset="0"/>
+                        <a:cs typeface="맑은 고딕" charset="0"/>
+                      </a:endParaRPr>
+                    </a:p>
+                  </a:txBody>
+                  <a:tcPr marL="45720" marR="45720" marT="18288" marB="18288" anchor="ctr">
+                    <a:lnL w="9525" cap="flat" cmpd="sng" algn="ctr">
+                      <a:solidFill>
+                        <a:srgbClr val="BFC5CF"/>
+                      </a:solidFill>
+                      <a:prstDash val="solid"/>
+                      <a:round/>
+                      <a:headEnd type="none" w="med" len="med"/>
+                      <a:tailEnd type="none" w="med" len="med"/>
+                    </a:lnL>
+                    <a:lnR w="9525" cap="flat" cmpd="sng" algn="ctr">
+                      <a:solidFill>
+                        <a:srgbClr val="BFC5CF"/>
+                      </a:solidFill>
+                      <a:prstDash val="solid"/>
+                      <a:round/>
+                      <a:headEnd type="none" w="med" len="med"/>
+                      <a:tailEnd type="none" w="med" len="med"/>
+                    </a:lnR>
+                    <a:lnT w="9525" cap="flat" cmpd="sng" algn="ctr">
+                      <a:solidFill>
+                        <a:srgbClr val="BFC5CF"/>
+                      </a:solidFill>
+                      <a:prstDash val="solid"/>
+                      <a:round/>
+                      <a:headEnd type="none" w="med" len="med"/>
+                      <a:tailEnd type="none" w="med" len="med"/>
+                    </a:lnT>
+                    <a:lnB w="9525" cap="flat" cmpd="sng" algn="ctr">
+                      <a:solidFill>
+                        <a:srgbClr val="BFC5CF"/>
+                      </a:solidFill>
+                      <a:prstDash val="solid"/>
+                      <a:round/>
+                      <a:headEnd type="none" w="med" len="med"/>
+                      <a:tailEnd type="none" w="med" len="med"/>
+                    </a:lnB>
+                  </a:tcPr>
+                </a:tc>
+                <a:tc>
+                  <a:txBody>
+                    <a:bodyPr/>
+                    <a:lstStyle/>
+                    <a:p>
+                      <a:pPr indent="0" marL="0">
+                        <a:buNone/>
+                      </a:pPr>
+                      <a:r>
+                        <a:rPr lang="en-US" sz="900" dirty="0">
+                          <a:solidFill>
+                            <a:srgbClr val="1F2329"/>
+                          </a:solidFill>
+                          <a:latin typeface="맑은 고딕" pitchFamily="34" charset="0"/>
+                          <a:ea typeface="맑은 고딕" pitchFamily="34" charset="-122"/>
+                          <a:cs typeface="맑은 고딕" pitchFamily="34" charset="-120"/>
+                        </a:rPr>
+                        <a:t>PI To-Be·도메인 분석으로 Target 선정, KPI 먼저 정의 (과제 Pool 108건)</a:t>
+                      </a:r>
+                      <a:endParaRPr lang="en-US" sz="900" dirty="0">
+                        <a:latin typeface="맑은 고딕" charset="0"/>
+                        <a:ea typeface="맑은 고딕" charset="0"/>
+                        <a:cs typeface="맑은 고딕" charset="0"/>
+                      </a:endParaRPr>
+                    </a:p>
+                  </a:txBody>
+                  <a:tcPr marL="45720" marR="45720" marT="18288" marB="18288" anchor="ctr">
+                    <a:lnL w="9525" cap="flat" cmpd="sng" algn="ctr">
+                      <a:solidFill>
+                        <a:srgbClr val="BFC5CF"/>
+                      </a:solidFill>
+                      <a:prstDash val="solid"/>
+                      <a:round/>
+                      <a:headEnd type="none" w="med" len="med"/>
+                      <a:tailEnd type="none" w="med" len="med"/>
+                    </a:lnL>
+                    <a:lnR w="9525" cap="flat" cmpd="sng" algn="ctr">
+                      <a:solidFill>
+                        <a:srgbClr val="BFC5CF"/>
+                      </a:solidFill>
+                      <a:prstDash val="solid"/>
+                      <a:round/>
+                      <a:headEnd type="none" w="med" len="med"/>
+                      <a:tailEnd type="none" w="med" len="med"/>
+                    </a:lnR>
+                    <a:lnT w="9525" cap="flat" cmpd="sng" algn="ctr">
+                      <a:solidFill>
+                        <a:srgbClr val="BFC5CF"/>
+                      </a:solidFill>
+                      <a:prstDash val="solid"/>
+                      <a:round/>
+                      <a:headEnd type="none" w="med" len="med"/>
+                      <a:tailEnd type="none" w="med" len="med"/>
+                    </a:lnT>
+                    <a:lnB w="9525" cap="flat" cmpd="sng" algn="ctr">
+                      <a:solidFill>
+                        <a:srgbClr val="BFC5CF"/>
+                      </a:solidFill>
+                      <a:prstDash val="solid"/>
+                      <a:round/>
+                      <a:headEnd type="none" w="med" len="med"/>
+                      <a:tailEnd type="none" w="med" len="med"/>
+                    </a:lnB>
+                  </a:tcPr>
+                </a:tc>
+                <a:tc>
+                  <a:txBody>
+                    <a:bodyPr/>
+                    <a:lstStyle/>
+                    <a:p>
+                      <a:pPr algn="ctr" indent="0" marL="0">
+                        <a:buNone/>
+                      </a:pPr>
+                      <a:r>
+                        <a:rPr lang="en-US" sz="900" b="1" dirty="0">
+                          <a:solidFill>
+                            <a:srgbClr val="1F2329"/>
+                          </a:solidFill>
+                          <a:latin typeface="맑은 고딕" pitchFamily="34" charset="0"/>
+                          <a:ea typeface="맑은 고딕" pitchFamily="34" charset="-122"/>
+                          <a:cs typeface="맑은 고딕" pitchFamily="34" charset="-120"/>
+                        </a:rPr>
+                        <a:t>Biz·AX</a:t>
+                      </a:r>
+                      <a:endParaRPr lang="en-US" sz="900" dirty="0">
+                        <a:latin typeface="맑은 고딕" charset="0"/>
+                        <a:ea typeface="맑은 고딕" charset="0"/>
+                        <a:cs typeface="맑은 고딕" charset="0"/>
+                      </a:endParaRPr>
+                    </a:p>
+                  </a:txBody>
+                  <a:tcPr marL="45720" marR="45720" marT="18288" marB="18288" anchor="ctr">
+                    <a:lnL w="9525" cap="flat" cmpd="sng" algn="ctr">
+                      <a:solidFill>
+                        <a:srgbClr val="BFC5CF"/>
+                      </a:solidFill>
+                      <a:prstDash val="solid"/>
+                      <a:round/>
+                      <a:headEnd type="none" w="med" len="med"/>
+                      <a:tailEnd type="none" w="med" len="med"/>
+                    </a:lnL>
+                    <a:lnR w="9525" cap="flat" cmpd="sng" algn="ctr">
+                      <a:solidFill>
+                        <a:srgbClr val="BFC5CF"/>
+                      </a:solidFill>
+                      <a:prstDash val="solid"/>
+                      <a:round/>
+                      <a:headEnd type="none" w="med" len="med"/>
+                      <a:tailEnd type="none" w="med" len="med"/>
+                    </a:lnR>
+                    <a:lnT w="9525" cap="flat" cmpd="sng" algn="ctr">
+                      <a:solidFill>
+                        <a:srgbClr val="BFC5CF"/>
+                      </a:solidFill>
+                      <a:prstDash val="solid"/>
+                      <a:round/>
+                      <a:headEnd type="none" w="med" len="med"/>
+                      <a:tailEnd type="none" w="med" len="med"/>
+                    </a:lnT>
+                    <a:lnB w="9525" cap="flat" cmpd="sng" algn="ctr">
+                      <a:solidFill>
+                        <a:srgbClr val="BFC5CF"/>
+                      </a:solidFill>
+                      <a:prstDash val="solid"/>
+                      <a:round/>
+                      <a:headEnd type="none" w="med" len="med"/>
+                      <a:tailEnd type="none" w="med" len="med"/>
+                    </a:lnB>
+                  </a:tcPr>
+                </a:tc>
+                <a:tc>
+                  <a:txBody>
+                    <a:bodyPr/>
+                    <a:lstStyle/>
+                    <a:p>
+                      <a:pPr algn="ctr" indent="0" marL="0">
+                        <a:buNone/>
+                      </a:pPr>
+                      <a:r>
+                        <a:rPr lang="en-US" sz="1300" dirty="0">
+                          <a:solidFill>
+                            <a:srgbClr val="1F4E9A"/>
+                          </a:solidFill>
+                          <a:latin typeface="맑은 고딕" pitchFamily="34" charset="0"/>
+                          <a:ea typeface="맑은 고딕" pitchFamily="34" charset="-122"/>
+                          <a:cs typeface="맑은 고딕" pitchFamily="34" charset="-120"/>
+                        </a:rPr>
+                        <a:t>●</a:t>
+                      </a:r>
+                      <a:endParaRPr lang="en-US" sz="1300" dirty="0">
+                        <a:latin typeface="맑은 고딕" charset="0"/>
+                        <a:ea typeface="맑은 고딕" charset="0"/>
+                        <a:cs typeface="맑은 고딕" charset="0"/>
+                      </a:endParaRPr>
+                    </a:p>
+                  </a:txBody>
+                  <a:tcPr marL="45720" marR="45720" marT="18288" marB="18288" anchor="ctr">
+                    <a:lnL w="9525" cap="flat" cmpd="sng" algn="ctr">
+                      <a:solidFill>
+                        <a:srgbClr val="BFC5CF"/>
+                      </a:solidFill>
+                      <a:prstDash val="solid"/>
+                      <a:round/>
+                      <a:headEnd type="none" w="med" len="med"/>
+                      <a:tailEnd type="none" w="med" len="med"/>
+                    </a:lnL>
+                    <a:lnR w="9525" cap="flat" cmpd="sng" algn="ctr">
+                      <a:solidFill>
+                        <a:srgbClr val="BFC5CF"/>
+                      </a:solidFill>
+                      <a:prstDash val="solid"/>
+                      <a:round/>
+                      <a:headEnd type="none" w="med" len="med"/>
+                      <a:tailEnd type="none" w="med" len="med"/>
+                    </a:lnR>
+                    <a:lnT w="9525" cap="flat" cmpd="sng" algn="ctr">
+                      <a:solidFill>
+                        <a:srgbClr val="BFC5CF"/>
+                      </a:solidFill>
+                      <a:prstDash val="solid"/>
+                      <a:round/>
+                      <a:headEnd type="none" w="med" len="med"/>
+                      <a:tailEnd type="none" w="med" len="med"/>
+                    </a:lnT>
+                    <a:lnB w="9525" cap="flat" cmpd="sng" algn="ctr">
+                      <a:solidFill>
+                        <a:srgbClr val="BFC5CF"/>
+                      </a:solidFill>
+                      <a:prstDash val="solid"/>
+                      <a:round/>
+                      <a:headEnd type="none" w="med" len="med"/>
+                      <a:tailEnd type="none" w="med" len="med"/>
+                    </a:lnB>
+                  </a:tcPr>
+                </a:tc>
+              </a:tr>
+              <a:tr h="512064">
+                <a:tc>
+                  <a:txBody>
+                    <a:bodyPr/>
+                    <a:lstStyle/>
+                    <a:p>
+                      <a:pPr indent="0" marL="0">
+                        <a:buNone/>
+                      </a:pPr>
+                      <a:r>
+                        <a:rPr lang="en-US" sz="950" b="1" dirty="0">
+                          <a:solidFill>
+                            <a:srgbClr val="2F3E55"/>
+                          </a:solidFill>
+                          <a:latin typeface="맑은 고딕" pitchFamily="34" charset="0"/>
+                          <a:ea typeface="맑은 고딕" pitchFamily="34" charset="-122"/>
+                          <a:cs typeface="맑은 고딕" pitchFamily="34" charset="-120"/>
+                        </a:rPr>
+                        <a:t>2. 현업이 유스케이스 주인</a:t>
+                      </a:r>
+                      <a:endParaRPr lang="en-US" sz="900" dirty="0">
+                        <a:latin typeface="맑은 고딕" charset="0"/>
+                        <a:ea typeface="맑은 고딕" charset="0"/>
+                        <a:cs typeface="맑은 고딕" charset="0"/>
+                      </a:endParaRPr>
+                    </a:p>
+                    <a:p>
+                      <a:pPr indent="0" marL="0">
+                        <a:buNone/>
+                      </a:pPr>
+                      <a:r>
+                        <a:rPr lang="en-US" sz="800" dirty="0">
+                          <a:solidFill>
+                            <a:srgbClr val="5B6B82"/>
+                          </a:solidFill>
+                          <a:latin typeface="맑은 고딕" pitchFamily="34" charset="0"/>
+                          <a:ea typeface="맑은 고딕" pitchFamily="34" charset="-122"/>
+                          <a:cs typeface="맑은 고딕" pitchFamily="34" charset="-120"/>
+                        </a:rPr>
+                        <a:t>IT 단독 추진 시 채택률 저하</a:t>
+                      </a:r>
+                      <a:endParaRPr lang="en-US" sz="900" dirty="0">
+                        <a:latin typeface="맑은 고딕" charset="0"/>
+                        <a:ea typeface="맑은 고딕" charset="0"/>
+                        <a:cs typeface="맑은 고딕" charset="0"/>
+                      </a:endParaRPr>
+                    </a:p>
+                  </a:txBody>
+                  <a:tcPr marL="45720" marR="45720" marT="18288" marB="18288" anchor="ctr">
+                    <a:lnL w="9525" cap="flat" cmpd="sng" algn="ctr">
+                      <a:solidFill>
+                        <a:srgbClr val="BFC5CF"/>
+                      </a:solidFill>
+                      <a:prstDash val="solid"/>
+                      <a:round/>
+                      <a:headEnd type="none" w="med" len="med"/>
+                      <a:tailEnd type="none" w="med" len="med"/>
+                    </a:lnL>
+                    <a:lnR w="9525" cap="flat" cmpd="sng" algn="ctr">
+                      <a:solidFill>
+                        <a:srgbClr val="BFC5CF"/>
+                      </a:solidFill>
+                      <a:prstDash val="solid"/>
+                      <a:round/>
+                      <a:headEnd type="none" w="med" len="med"/>
+                      <a:tailEnd type="none" w="med" len="med"/>
+                    </a:lnR>
+                    <a:lnT w="9525" cap="flat" cmpd="sng" algn="ctr">
+                      <a:solidFill>
+                        <a:srgbClr val="BFC5CF"/>
+                      </a:solidFill>
+                      <a:prstDash val="solid"/>
+                      <a:round/>
+                      <a:headEnd type="none" w="med" len="med"/>
+                      <a:tailEnd type="none" w="med" len="med"/>
+                    </a:lnT>
+                    <a:lnB w="9525" cap="flat" cmpd="sng" algn="ctr">
+                      <a:solidFill>
+                        <a:srgbClr val="BFC5CF"/>
+                      </a:solidFill>
+                      <a:prstDash val="solid"/>
+                      <a:round/>
+                      <a:headEnd type="none" w="med" len="med"/>
+                      <a:tailEnd type="none" w="med" len="med"/>
+                    </a:lnB>
+                  </a:tcPr>
+                </a:tc>
+                <a:tc>
+                  <a:txBody>
+                    <a:bodyPr/>
+                    <a:lstStyle/>
+                    <a:p>
+                      <a:pPr indent="0" marL="0">
+                        <a:buNone/>
+                      </a:pPr>
+                      <a:r>
+                        <a:rPr lang="en-US" sz="900" dirty="0">
+                          <a:solidFill>
+                            <a:srgbClr val="1F2329"/>
+                          </a:solidFill>
+                          <a:latin typeface="맑은 고딕" pitchFamily="34" charset="0"/>
+                          <a:ea typeface="맑은 고딕" pitchFamily="34" charset="-122"/>
+                          <a:cs typeface="맑은 고딕" pitchFamily="34" charset="-120"/>
+                        </a:rPr>
+                        <a:t>AX CAMP로 현업이 과제 직접 도출, 현업 Sponsor 확보 후 착수 (교육 6건)</a:t>
+                      </a:r>
+                      <a:endParaRPr lang="en-US" sz="900" dirty="0">
+                        <a:latin typeface="맑은 고딕" charset="0"/>
+                        <a:ea typeface="맑은 고딕" charset="0"/>
+                        <a:cs typeface="맑은 고딕" charset="0"/>
+                      </a:endParaRPr>
+                    </a:p>
+                  </a:txBody>
+                  <a:tcPr marL="45720" marR="45720" marT="18288" marB="18288" anchor="ctr">
+                    <a:lnL w="9525" cap="flat" cmpd="sng" algn="ctr">
+                      <a:solidFill>
+                        <a:srgbClr val="BFC5CF"/>
+                      </a:solidFill>
+                      <a:prstDash val="solid"/>
+                      <a:round/>
+                      <a:headEnd type="none" w="med" len="med"/>
+                      <a:tailEnd type="none" w="med" len="med"/>
+                    </a:lnL>
+                    <a:lnR w="9525" cap="flat" cmpd="sng" algn="ctr">
+                      <a:solidFill>
+                        <a:srgbClr val="BFC5CF"/>
+                      </a:solidFill>
+                      <a:prstDash val="solid"/>
+                      <a:round/>
+                      <a:headEnd type="none" w="med" len="med"/>
+                      <a:tailEnd type="none" w="med" len="med"/>
+                    </a:lnR>
+                    <a:lnT w="9525" cap="flat" cmpd="sng" algn="ctr">
+                      <a:solidFill>
+                        <a:srgbClr val="BFC5CF"/>
+                      </a:solidFill>
+                      <a:prstDash val="solid"/>
+                      <a:round/>
+                      <a:headEnd type="none" w="med" len="med"/>
+                      <a:tailEnd type="none" w="med" len="med"/>
+                    </a:lnT>
+                    <a:lnB w="9525" cap="flat" cmpd="sng" algn="ctr">
+                      <a:solidFill>
+                        <a:srgbClr val="BFC5CF"/>
+                      </a:solidFill>
+                      <a:prstDash val="solid"/>
+                      <a:round/>
+                      <a:headEnd type="none" w="med" len="med"/>
+                      <a:tailEnd type="none" w="med" len="med"/>
+                    </a:lnB>
+                  </a:tcPr>
+                </a:tc>
+                <a:tc>
+                  <a:txBody>
+                    <a:bodyPr/>
+                    <a:lstStyle/>
+                    <a:p>
+                      <a:pPr algn="ctr" indent="0" marL="0">
+                        <a:buNone/>
+                      </a:pPr>
+                      <a:r>
+                        <a:rPr lang="en-US" sz="900" b="1" dirty="0">
+                          <a:solidFill>
+                            <a:srgbClr val="1F2329"/>
+                          </a:solidFill>
+                          <a:latin typeface="맑은 고딕" pitchFamily="34" charset="0"/>
+                          <a:ea typeface="맑은 고딕" pitchFamily="34" charset="-122"/>
+                          <a:cs typeface="맑은 고딕" pitchFamily="34" charset="-120"/>
+                        </a:rPr>
+                        <a:t>AX</a:t>
+                      </a:r>
+                      <a:endParaRPr lang="en-US" sz="900" dirty="0">
+                        <a:latin typeface="맑은 고딕" charset="0"/>
+                        <a:ea typeface="맑은 고딕" charset="0"/>
+                        <a:cs typeface="맑은 고딕" charset="0"/>
+                      </a:endParaRPr>
+                    </a:p>
+                  </a:txBody>
+                  <a:tcPr marL="45720" marR="45720" marT="18288" marB="18288" anchor="ctr">
+                    <a:lnL w="9525" cap="flat" cmpd="sng" algn="ctr">
+                      <a:solidFill>
+                        <a:srgbClr val="BFC5CF"/>
+                      </a:solidFill>
+                      <a:prstDash val="solid"/>
+                      <a:round/>
+                      <a:headEnd type="none" w="med" len="med"/>
+                      <a:tailEnd type="none" w="med" len="med"/>
+                    </a:lnL>
+                    <a:lnR w="9525" cap="flat" cmpd="sng" algn="ctr">
+                      <a:solidFill>
+                        <a:srgbClr val="BFC5CF"/>
+                      </a:solidFill>
+                      <a:prstDash val="solid"/>
+                      <a:round/>
+                      <a:headEnd type="none" w="med" len="med"/>
+                      <a:tailEnd type="none" w="med" len="med"/>
+                    </a:lnR>
+                    <a:lnT w="9525" cap="flat" cmpd="sng" algn="ctr">
+                      <a:solidFill>
+                        <a:srgbClr val="BFC5CF"/>
+                      </a:solidFill>
+                      <a:prstDash val="solid"/>
+                      <a:round/>
+                      <a:headEnd type="none" w="med" len="med"/>
+                      <a:tailEnd type="none" w="med" len="med"/>
+                    </a:lnT>
+                    <a:lnB w="9525" cap="flat" cmpd="sng" algn="ctr">
+                      <a:solidFill>
+                        <a:srgbClr val="BFC5CF"/>
+                      </a:solidFill>
+                      <a:prstDash val="solid"/>
+                      <a:round/>
+                      <a:headEnd type="none" w="med" len="med"/>
+                      <a:tailEnd type="none" w="med" len="med"/>
+                    </a:lnB>
+                  </a:tcPr>
+                </a:tc>
+                <a:tc>
+                  <a:txBody>
+                    <a:bodyPr/>
+                    <a:lstStyle/>
+                    <a:p>
+                      <a:pPr algn="ctr" indent="0" marL="0">
+                        <a:buNone/>
+                      </a:pPr>
+                      <a:r>
+                        <a:rPr lang="en-US" sz="1300" dirty="0">
+                          <a:solidFill>
+                            <a:srgbClr val="1F4E9A"/>
+                          </a:solidFill>
+                          <a:latin typeface="맑은 고딕" pitchFamily="34" charset="0"/>
+                          <a:ea typeface="맑은 고딕" pitchFamily="34" charset="-122"/>
+                          <a:cs typeface="맑은 고딕" pitchFamily="34" charset="-120"/>
+                        </a:rPr>
+                        <a:t>●</a:t>
+                      </a:r>
+                      <a:endParaRPr lang="en-US" sz="1300" dirty="0">
+                        <a:latin typeface="맑은 고딕" charset="0"/>
+                        <a:ea typeface="맑은 고딕" charset="0"/>
+                        <a:cs typeface="맑은 고딕" charset="0"/>
+                      </a:endParaRPr>
+                    </a:p>
+                  </a:txBody>
+                  <a:tcPr marL="45720" marR="45720" marT="18288" marB="18288" anchor="ctr">
+                    <a:lnL w="9525" cap="flat" cmpd="sng" algn="ctr">
+                      <a:solidFill>
+                        <a:srgbClr val="BFC5CF"/>
+                      </a:solidFill>
+                      <a:prstDash val="solid"/>
+                      <a:round/>
+                      <a:headEnd type="none" w="med" len="med"/>
+                      <a:tailEnd type="none" w="med" len="med"/>
+                    </a:lnL>
+                    <a:lnR w="9525" cap="flat" cmpd="sng" algn="ctr">
+                      <a:solidFill>
+                        <a:srgbClr val="BFC5CF"/>
+                      </a:solidFill>
+                      <a:prstDash val="solid"/>
+                      <a:round/>
+                      <a:headEnd type="none" w="med" len="med"/>
+                      <a:tailEnd type="none" w="med" len="med"/>
+                    </a:lnR>
+                    <a:lnT w="9525" cap="flat" cmpd="sng" algn="ctr">
+                      <a:solidFill>
+                        <a:srgbClr val="BFC5CF"/>
+                      </a:solidFill>
+                      <a:prstDash val="solid"/>
+                      <a:round/>
+                      <a:headEnd type="none" w="med" len="med"/>
+                      <a:tailEnd type="none" w="med" len="med"/>
+                    </a:lnT>
+                    <a:lnB w="9525" cap="flat" cmpd="sng" algn="ctr">
+                      <a:solidFill>
+                        <a:srgbClr val="BFC5CF"/>
+                      </a:solidFill>
+                      <a:prstDash val="solid"/>
+                      <a:round/>
+                      <a:headEnd type="none" w="med" len="med"/>
+                      <a:tailEnd type="none" w="med" len="med"/>
+                    </a:lnB>
+                  </a:tcPr>
+                </a:tc>
+              </a:tr>
+              <a:tr h="512064">
+                <a:tc>
+                  <a:txBody>
+                    <a:bodyPr/>
+                    <a:lstStyle/>
+                    <a:p>
+                      <a:pPr indent="0" marL="0">
+                        <a:buNone/>
+                      </a:pPr>
+                      <a:r>
+                        <a:rPr lang="en-US" sz="950" b="1" dirty="0">
+                          <a:solidFill>
+                            <a:srgbClr val="2F3E55"/>
+                          </a:solidFill>
+                          <a:latin typeface="맑은 고딕" pitchFamily="34" charset="0"/>
+                          <a:ea typeface="맑은 고딕" pitchFamily="34" charset="-122"/>
+                          <a:cs typeface="맑은 고딕" pitchFamily="34" charset="-120"/>
+                        </a:rPr>
+                        <a:t>3. PoC와 전사 확산 구분</a:t>
+                      </a:r>
+                      <a:endParaRPr lang="en-US" sz="900" dirty="0">
+                        <a:latin typeface="맑은 고딕" charset="0"/>
+                        <a:ea typeface="맑은 고딕" charset="0"/>
+                        <a:cs typeface="맑은 고딕" charset="0"/>
+                      </a:endParaRPr>
+                    </a:p>
+                    <a:p>
+                      <a:pPr indent="0" marL="0">
+                        <a:buNone/>
+                      </a:pPr>
+                      <a:r>
+                        <a:rPr lang="en-US" sz="800" dirty="0">
+                          <a:solidFill>
+                            <a:srgbClr val="5B6B82"/>
+                          </a:solidFill>
+                          <a:latin typeface="맑은 고딕" pitchFamily="34" charset="0"/>
+                          <a:ea typeface="맑은 고딕" pitchFamily="34" charset="-122"/>
+                          <a:cs typeface="맑은 고딕" pitchFamily="34" charset="-120"/>
+                        </a:rPr>
+                        <a:t>PoC=기술검증, 확산=프로세스·조직 변화</a:t>
+                      </a:r>
+                      <a:endParaRPr lang="en-US" sz="900" dirty="0">
+                        <a:latin typeface="맑은 고딕" charset="0"/>
+                        <a:ea typeface="맑은 고딕" charset="0"/>
+                        <a:cs typeface="맑은 고딕" charset="0"/>
+                      </a:endParaRPr>
+                    </a:p>
+                  </a:txBody>
+                  <a:tcPr marL="45720" marR="45720" marT="18288" marB="18288" anchor="ctr">
+                    <a:lnL w="9525" cap="flat" cmpd="sng" algn="ctr">
+                      <a:solidFill>
+                        <a:srgbClr val="BFC5CF"/>
+                      </a:solidFill>
+                      <a:prstDash val="solid"/>
+                      <a:round/>
+                      <a:headEnd type="none" w="med" len="med"/>
+                      <a:tailEnd type="none" w="med" len="med"/>
+                    </a:lnL>
+                    <a:lnR w="9525" cap="flat" cmpd="sng" algn="ctr">
+                      <a:solidFill>
+                        <a:srgbClr val="BFC5CF"/>
+                      </a:solidFill>
+                      <a:prstDash val="solid"/>
+                      <a:round/>
+                      <a:headEnd type="none" w="med" len="med"/>
+                      <a:tailEnd type="none" w="med" len="med"/>
+                    </a:lnR>
+                    <a:lnT w="9525" cap="flat" cmpd="sng" algn="ctr">
+                      <a:solidFill>
+                        <a:srgbClr val="BFC5CF"/>
+                      </a:solidFill>
+                      <a:prstDash val="solid"/>
+                      <a:round/>
+                      <a:headEnd type="none" w="med" len="med"/>
+                      <a:tailEnd type="none" w="med" len="med"/>
+                    </a:lnT>
+                    <a:lnB w="9525" cap="flat" cmpd="sng" algn="ctr">
+                      <a:solidFill>
+                        <a:srgbClr val="BFC5CF"/>
+                      </a:solidFill>
+                      <a:prstDash val="solid"/>
+                      <a:round/>
+                      <a:headEnd type="none" w="med" len="med"/>
+                      <a:tailEnd type="none" w="med" len="med"/>
+                    </a:lnB>
+                  </a:tcPr>
+                </a:tc>
+                <a:tc>
+                  <a:txBody>
+                    <a:bodyPr/>
+                    <a:lstStyle/>
+                    <a:p>
+                      <a:pPr indent="0" marL="0">
+                        <a:buNone/>
+                      </a:pPr>
+                      <a:r>
+                        <a:rPr lang="en-US" sz="900" dirty="0">
+                          <a:solidFill>
+                            <a:srgbClr val="1F2329"/>
+                          </a:solidFill>
+                          <a:latin typeface="맑은 고딕" pitchFamily="34" charset="0"/>
+                          <a:ea typeface="맑은 고딕" pitchFamily="34" charset="-122"/>
+                          <a:cs typeface="맑은 고딕" pitchFamily="34" charset="-120"/>
+                        </a:rPr>
+                        <a:t>MVP(L1~L2) → Go/No-go → 운영 이관·구축사업화 단계 분리</a:t>
+                      </a:r>
+                      <a:endParaRPr lang="en-US" sz="900" dirty="0">
+                        <a:latin typeface="맑은 고딕" charset="0"/>
+                        <a:ea typeface="맑은 고딕" charset="0"/>
+                        <a:cs typeface="맑은 고딕" charset="0"/>
+                      </a:endParaRPr>
+                    </a:p>
+                  </a:txBody>
+                  <a:tcPr marL="45720" marR="45720" marT="18288" marB="18288" anchor="ctr">
+                    <a:lnL w="9525" cap="flat" cmpd="sng" algn="ctr">
+                      <a:solidFill>
+                        <a:srgbClr val="BFC5CF"/>
+                      </a:solidFill>
+                      <a:prstDash val="solid"/>
+                      <a:round/>
+                      <a:headEnd type="none" w="med" len="med"/>
+                      <a:tailEnd type="none" w="med" len="med"/>
+                    </a:lnL>
+                    <a:lnR w="9525" cap="flat" cmpd="sng" algn="ctr">
+                      <a:solidFill>
+                        <a:srgbClr val="BFC5CF"/>
+                      </a:solidFill>
+                      <a:prstDash val="solid"/>
+                      <a:round/>
+                      <a:headEnd type="none" w="med" len="med"/>
+                      <a:tailEnd type="none" w="med" len="med"/>
+                    </a:lnR>
+                    <a:lnT w="9525" cap="flat" cmpd="sng" algn="ctr">
+                      <a:solidFill>
+                        <a:srgbClr val="BFC5CF"/>
+                      </a:solidFill>
+                      <a:prstDash val="solid"/>
+                      <a:round/>
+                      <a:headEnd type="none" w="med" len="med"/>
+                      <a:tailEnd type="none" w="med" len="med"/>
+                    </a:lnT>
+                    <a:lnB w="9525" cap="flat" cmpd="sng" algn="ctr">
+                      <a:solidFill>
+                        <a:srgbClr val="BFC5CF"/>
+                      </a:solidFill>
+                      <a:prstDash val="solid"/>
+                      <a:round/>
+                      <a:headEnd type="none" w="med" len="med"/>
+                      <a:tailEnd type="none" w="med" len="med"/>
+                    </a:lnB>
+                  </a:tcPr>
+                </a:tc>
+                <a:tc>
+                  <a:txBody>
+                    <a:bodyPr/>
+                    <a:lstStyle/>
+                    <a:p>
+                      <a:pPr algn="ctr" indent="0" marL="0">
+                        <a:buNone/>
+                      </a:pPr>
+                      <a:r>
+                        <a:rPr lang="en-US" sz="900" b="1" dirty="0">
+                          <a:solidFill>
+                            <a:srgbClr val="1F2329"/>
+                          </a:solidFill>
+                          <a:latin typeface="맑은 고딕" pitchFamily="34" charset="0"/>
+                          <a:ea typeface="맑은 고딕" pitchFamily="34" charset="-122"/>
+                          <a:cs typeface="맑은 고딕" pitchFamily="34" charset="-120"/>
+                        </a:rPr>
+                        <a:t>AX·엔지니어</a:t>
+                      </a:r>
+                      <a:endParaRPr lang="en-US" sz="900" dirty="0">
+                        <a:latin typeface="맑은 고딕" charset="0"/>
+                        <a:ea typeface="맑은 고딕" charset="0"/>
+                        <a:cs typeface="맑은 고딕" charset="0"/>
+                      </a:endParaRPr>
+                    </a:p>
+                  </a:txBody>
+                  <a:tcPr marL="45720" marR="45720" marT="18288" marB="18288" anchor="ctr">
+                    <a:lnL w="9525" cap="flat" cmpd="sng" algn="ctr">
+                      <a:solidFill>
+                        <a:srgbClr val="BFC5CF"/>
+                      </a:solidFill>
+                      <a:prstDash val="solid"/>
+                      <a:round/>
+                      <a:headEnd type="none" w="med" len="med"/>
+                      <a:tailEnd type="none" w="med" len="med"/>
+                    </a:lnL>
+                    <a:lnR w="9525" cap="flat" cmpd="sng" algn="ctr">
+                      <a:solidFill>
+                        <a:srgbClr val="BFC5CF"/>
+                      </a:solidFill>
+                      <a:prstDash val="solid"/>
+                      <a:round/>
+                      <a:headEnd type="none" w="med" len="med"/>
+                      <a:tailEnd type="none" w="med" len="med"/>
+                    </a:lnR>
+                    <a:lnT w="9525" cap="flat" cmpd="sng" algn="ctr">
+                      <a:solidFill>
+                        <a:srgbClr val="BFC5CF"/>
+                      </a:solidFill>
+                      <a:prstDash val="solid"/>
+                      <a:round/>
+                      <a:headEnd type="none" w="med" len="med"/>
+                      <a:tailEnd type="none" w="med" len="med"/>
+                    </a:lnT>
+                    <a:lnB w="9525" cap="flat" cmpd="sng" algn="ctr">
+                      <a:solidFill>
+                        <a:srgbClr val="BFC5CF"/>
+                      </a:solidFill>
+                      <a:prstDash val="solid"/>
+                      <a:round/>
+                      <a:headEnd type="none" w="med" len="med"/>
+                      <a:tailEnd type="none" w="med" len="med"/>
+                    </a:lnB>
+                  </a:tcPr>
+                </a:tc>
+                <a:tc>
+                  <a:txBody>
+                    <a:bodyPr/>
+                    <a:lstStyle/>
+                    <a:p>
+                      <a:pPr algn="ctr" indent="0" marL="0">
+                        <a:buNone/>
+                      </a:pPr>
+                      <a:r>
+                        <a:rPr lang="en-US" sz="1300" dirty="0">
+                          <a:solidFill>
+                            <a:srgbClr val="1F4E9A"/>
+                          </a:solidFill>
+                          <a:latin typeface="맑은 고딕" pitchFamily="34" charset="0"/>
+                          <a:ea typeface="맑은 고딕" pitchFamily="34" charset="-122"/>
+                          <a:cs typeface="맑은 고딕" pitchFamily="34" charset="-120"/>
+                        </a:rPr>
+                        <a:t>◐</a:t>
+                      </a:r>
+                      <a:endParaRPr lang="en-US" sz="1300" dirty="0">
+                        <a:latin typeface="맑은 고딕" charset="0"/>
+                        <a:ea typeface="맑은 고딕" charset="0"/>
+                        <a:cs typeface="맑은 고딕" charset="0"/>
+                      </a:endParaRPr>
+                    </a:p>
+                  </a:txBody>
+                  <a:tcPr marL="45720" marR="45720" marT="18288" marB="18288" anchor="ctr">
+                    <a:lnL w="9525" cap="flat" cmpd="sng" algn="ctr">
+                      <a:solidFill>
+                        <a:srgbClr val="BFC5CF"/>
+                      </a:solidFill>
+                      <a:prstDash val="solid"/>
+                      <a:round/>
+                      <a:headEnd type="none" w="med" len="med"/>
+                      <a:tailEnd type="none" w="med" len="med"/>
+                    </a:lnL>
+                    <a:lnR w="9525" cap="flat" cmpd="sng" algn="ctr">
+                      <a:solidFill>
+                        <a:srgbClr val="BFC5CF"/>
+                      </a:solidFill>
+                      <a:prstDash val="solid"/>
+                      <a:round/>
+                      <a:headEnd type="none" w="med" len="med"/>
+                      <a:tailEnd type="none" w="med" len="med"/>
+                    </a:lnR>
+                    <a:lnT w="9525" cap="flat" cmpd="sng" algn="ctr">
+                      <a:solidFill>
+                        <a:srgbClr val="BFC5CF"/>
+                      </a:solidFill>
+                      <a:prstDash val="solid"/>
+                      <a:round/>
+                      <a:headEnd type="none" w="med" len="med"/>
+                      <a:tailEnd type="none" w="med" len="med"/>
+                    </a:lnT>
+                    <a:lnB w="9525" cap="flat" cmpd="sng" algn="ctr">
+                      <a:solidFill>
+                        <a:srgbClr val="BFC5CF"/>
+                      </a:solidFill>
+                      <a:prstDash val="solid"/>
+                      <a:round/>
+                      <a:headEnd type="none" w="med" len="med"/>
+                      <a:tailEnd type="none" w="med" len="med"/>
+                    </a:lnB>
+                  </a:tcPr>
+                </a:tc>
+              </a:tr>
+              <a:tr h="512064">
+                <a:tc>
+                  <a:txBody>
+                    <a:bodyPr/>
+                    <a:lstStyle/>
+                    <a:p>
+                      <a:pPr indent="0" marL="0">
+                        <a:buNone/>
+                      </a:pPr>
+                      <a:r>
+                        <a:rPr lang="en-US" sz="950" b="1" dirty="0">
+                          <a:solidFill>
+                            <a:srgbClr val="2F3E55"/>
+                          </a:solidFill>
+                          <a:latin typeface="맑은 고딕" pitchFamily="34" charset="0"/>
+                          <a:ea typeface="맑은 고딕" pitchFamily="34" charset="-122"/>
+                          <a:cs typeface="맑은 고딕" pitchFamily="34" charset="-120"/>
+                        </a:rPr>
+                        <a:t>4. 데이터·레거시 현대화 병행</a:t>
+                      </a:r>
+                      <a:endParaRPr lang="en-US" sz="900" dirty="0">
+                        <a:latin typeface="맑은 고딕" charset="0"/>
+                        <a:ea typeface="맑은 고딕" charset="0"/>
+                        <a:cs typeface="맑은 고딕" charset="0"/>
+                      </a:endParaRPr>
+                    </a:p>
+                    <a:p>
+                      <a:pPr indent="0" marL="0">
+                        <a:buNone/>
+                      </a:pPr>
+                      <a:r>
+                        <a:rPr lang="en-US" sz="800" dirty="0">
+                          <a:solidFill>
+                            <a:srgbClr val="5B6B82"/>
+                          </a:solidFill>
+                          <a:latin typeface="맑은 고딕" pitchFamily="34" charset="0"/>
+                          <a:ea typeface="맑은 고딕" pitchFamily="34" charset="-122"/>
+                          <a:cs typeface="맑은 고딕" pitchFamily="34" charset="-120"/>
+                        </a:rPr>
+                        <a:t>데이터 품질·시스템 연결성이 성과 좌우</a:t>
+                      </a:r>
+                      <a:endParaRPr lang="en-US" sz="900" dirty="0">
+                        <a:latin typeface="맑은 고딕" charset="0"/>
+                        <a:ea typeface="맑은 고딕" charset="0"/>
+                        <a:cs typeface="맑은 고딕" charset="0"/>
+                      </a:endParaRPr>
+                    </a:p>
+                  </a:txBody>
+                  <a:tcPr marL="45720" marR="45720" marT="18288" marB="18288" anchor="ctr">
+                    <a:lnL w="9525" cap="flat" cmpd="sng" algn="ctr">
+                      <a:solidFill>
+                        <a:srgbClr val="BFC5CF"/>
+                      </a:solidFill>
+                      <a:prstDash val="solid"/>
+                      <a:round/>
+                      <a:headEnd type="none" w="med" len="med"/>
+                      <a:tailEnd type="none" w="med" len="med"/>
+                    </a:lnL>
+                    <a:lnR w="9525" cap="flat" cmpd="sng" algn="ctr">
+                      <a:solidFill>
+                        <a:srgbClr val="BFC5CF"/>
+                      </a:solidFill>
+                      <a:prstDash val="solid"/>
+                      <a:round/>
+                      <a:headEnd type="none" w="med" len="med"/>
+                      <a:tailEnd type="none" w="med" len="med"/>
+                    </a:lnR>
+                    <a:lnT w="9525" cap="flat" cmpd="sng" algn="ctr">
+                      <a:solidFill>
+                        <a:srgbClr val="BFC5CF"/>
+                      </a:solidFill>
+                      <a:prstDash val="solid"/>
+                      <a:round/>
+                      <a:headEnd type="none" w="med" len="med"/>
+                      <a:tailEnd type="none" w="med" len="med"/>
+                    </a:lnT>
+                    <a:lnB w="9525" cap="flat" cmpd="sng" algn="ctr">
+                      <a:solidFill>
+                        <a:srgbClr val="BFC5CF"/>
+                      </a:solidFill>
+                      <a:prstDash val="solid"/>
+                      <a:round/>
+                      <a:headEnd type="none" w="med" len="med"/>
+                      <a:tailEnd type="none" w="med" len="med"/>
+                    </a:lnB>
+                  </a:tcPr>
+                </a:tc>
+                <a:tc>
+                  <a:txBody>
+                    <a:bodyPr/>
+                    <a:lstStyle/>
+                    <a:p>
+                      <a:pPr indent="0" marL="0">
+                        <a:buNone/>
+                      </a:pPr>
+                      <a:r>
+                        <a:rPr lang="en-US" sz="900" dirty="0">
+                          <a:solidFill>
+                            <a:srgbClr val="1F2329"/>
+                          </a:solidFill>
+                          <a:latin typeface="맑은 고딕" pitchFamily="34" charset="0"/>
+                          <a:ea typeface="맑은 고딕" pitchFamily="34" charset="-122"/>
+                          <a:cs typeface="맑은 고딕" pitchFamily="34" charset="-120"/>
+                        </a:rPr>
+                        <a:t>차세대 PI/ISP·SAP 사전진단 경험 + D&amp;AX 데이터·기간계 연동</a:t>
+                      </a:r>
+                      <a:endParaRPr lang="en-US" sz="900" dirty="0">
+                        <a:latin typeface="맑은 고딕" charset="0"/>
+                        <a:ea typeface="맑은 고딕" charset="0"/>
+                        <a:cs typeface="맑은 고딕" charset="0"/>
+                      </a:endParaRPr>
+                    </a:p>
+                  </a:txBody>
+                  <a:tcPr marL="45720" marR="45720" marT="18288" marB="18288" anchor="ctr">
+                    <a:lnL w="9525" cap="flat" cmpd="sng" algn="ctr">
+                      <a:solidFill>
+                        <a:srgbClr val="BFC5CF"/>
+                      </a:solidFill>
+                      <a:prstDash val="solid"/>
+                      <a:round/>
+                      <a:headEnd type="none" w="med" len="med"/>
+                      <a:tailEnd type="none" w="med" len="med"/>
+                    </a:lnL>
+                    <a:lnR w="9525" cap="flat" cmpd="sng" algn="ctr">
+                      <a:solidFill>
+                        <a:srgbClr val="BFC5CF"/>
+                      </a:solidFill>
+                      <a:prstDash val="solid"/>
+                      <a:round/>
+                      <a:headEnd type="none" w="med" len="med"/>
+                      <a:tailEnd type="none" w="med" len="med"/>
+                    </a:lnR>
+                    <a:lnT w="9525" cap="flat" cmpd="sng" algn="ctr">
+                      <a:solidFill>
+                        <a:srgbClr val="BFC5CF"/>
+                      </a:solidFill>
+                      <a:prstDash val="solid"/>
+                      <a:round/>
+                      <a:headEnd type="none" w="med" len="med"/>
+                      <a:tailEnd type="none" w="med" len="med"/>
+                    </a:lnT>
+                    <a:lnB w="9525" cap="flat" cmpd="sng" algn="ctr">
+                      <a:solidFill>
+                        <a:srgbClr val="BFC5CF"/>
+                      </a:solidFill>
+                      <a:prstDash val="solid"/>
+                      <a:round/>
+                      <a:headEnd type="none" w="med" len="med"/>
+                      <a:tailEnd type="none" w="med" len="med"/>
+                    </a:lnB>
+                  </a:tcPr>
+                </a:tc>
+                <a:tc>
+                  <a:txBody>
+                    <a:bodyPr/>
+                    <a:lstStyle/>
+                    <a:p>
+                      <a:pPr algn="ctr" indent="0" marL="0">
+                        <a:buNone/>
+                      </a:pPr>
+                      <a:r>
+                        <a:rPr lang="en-US" sz="900" b="1" dirty="0">
+                          <a:solidFill>
+                            <a:srgbClr val="1F2329"/>
+                          </a:solidFill>
+                          <a:latin typeface="맑은 고딕" pitchFamily="34" charset="0"/>
+                          <a:ea typeface="맑은 고딕" pitchFamily="34" charset="-122"/>
+                          <a:cs typeface="맑은 고딕" pitchFamily="34" charset="-120"/>
+                        </a:rPr>
+                        <a:t>Biz·D&amp;AX</a:t>
+                      </a:r>
+                      <a:endParaRPr lang="en-US" sz="900" dirty="0">
+                        <a:latin typeface="맑은 고딕" charset="0"/>
+                        <a:ea typeface="맑은 고딕" charset="0"/>
+                        <a:cs typeface="맑은 고딕" charset="0"/>
+                      </a:endParaRPr>
+                    </a:p>
+                  </a:txBody>
+                  <a:tcPr marL="45720" marR="45720" marT="18288" marB="18288" anchor="ctr">
+                    <a:lnL w="9525" cap="flat" cmpd="sng" algn="ctr">
+                      <a:solidFill>
+                        <a:srgbClr val="BFC5CF"/>
+                      </a:solidFill>
+                      <a:prstDash val="solid"/>
+                      <a:round/>
+                      <a:headEnd type="none" w="med" len="med"/>
+                      <a:tailEnd type="none" w="med" len="med"/>
+                    </a:lnL>
+                    <a:lnR w="9525" cap="flat" cmpd="sng" algn="ctr">
+                      <a:solidFill>
+                        <a:srgbClr val="BFC5CF"/>
+                      </a:solidFill>
+                      <a:prstDash val="solid"/>
+                      <a:round/>
+                      <a:headEnd type="none" w="med" len="med"/>
+                      <a:tailEnd type="none" w="med" len="med"/>
+                    </a:lnR>
+                    <a:lnT w="9525" cap="flat" cmpd="sng" algn="ctr">
+                      <a:solidFill>
+                        <a:srgbClr val="BFC5CF"/>
+                      </a:solidFill>
+                      <a:prstDash val="solid"/>
+                      <a:round/>
+                      <a:headEnd type="none" w="med" len="med"/>
+                      <a:tailEnd type="none" w="med" len="med"/>
+                    </a:lnT>
+                    <a:lnB w="9525" cap="flat" cmpd="sng" algn="ctr">
+                      <a:solidFill>
+                        <a:srgbClr val="BFC5CF"/>
+                      </a:solidFill>
+                      <a:prstDash val="solid"/>
+                      <a:round/>
+                      <a:headEnd type="none" w="med" len="med"/>
+                      <a:tailEnd type="none" w="med" len="med"/>
+                    </a:lnB>
+                  </a:tcPr>
+                </a:tc>
+                <a:tc>
+                  <a:txBody>
+                    <a:bodyPr/>
+                    <a:lstStyle/>
+                    <a:p>
+                      <a:pPr algn="ctr" indent="0" marL="0">
+                        <a:buNone/>
+                      </a:pPr>
+                      <a:r>
+                        <a:rPr lang="en-US" sz="1300" dirty="0">
+                          <a:solidFill>
+                            <a:srgbClr val="1F4E9A"/>
+                          </a:solidFill>
+                          <a:latin typeface="맑은 고딕" pitchFamily="34" charset="0"/>
+                          <a:ea typeface="맑은 고딕" pitchFamily="34" charset="-122"/>
+                          <a:cs typeface="맑은 고딕" pitchFamily="34" charset="-120"/>
+                        </a:rPr>
+                        <a:t>◐</a:t>
+                      </a:r>
+                      <a:endParaRPr lang="en-US" sz="1300" dirty="0">
+                        <a:latin typeface="맑은 고딕" charset="0"/>
+                        <a:ea typeface="맑은 고딕" charset="0"/>
+                        <a:cs typeface="맑은 고딕" charset="0"/>
+                      </a:endParaRPr>
+                    </a:p>
+                  </a:txBody>
+                  <a:tcPr marL="45720" marR="45720" marT="18288" marB="18288" anchor="ctr">
+                    <a:lnL w="9525" cap="flat" cmpd="sng" algn="ctr">
+                      <a:solidFill>
+                        <a:srgbClr val="BFC5CF"/>
+                      </a:solidFill>
+                      <a:prstDash val="solid"/>
+                      <a:round/>
+                      <a:headEnd type="none" w="med" len="med"/>
+                      <a:tailEnd type="none" w="med" len="med"/>
+                    </a:lnL>
+                    <a:lnR w="9525" cap="flat" cmpd="sng" algn="ctr">
+                      <a:solidFill>
+                        <a:srgbClr val="BFC5CF"/>
+                      </a:solidFill>
+                      <a:prstDash val="solid"/>
+                      <a:round/>
+                      <a:headEnd type="none" w="med" len="med"/>
+                      <a:tailEnd type="none" w="med" len="med"/>
+                    </a:lnR>
+                    <a:lnT w="9525" cap="flat" cmpd="sng" algn="ctr">
+                      <a:solidFill>
+                        <a:srgbClr val="BFC5CF"/>
+                      </a:solidFill>
+                      <a:prstDash val="solid"/>
+                      <a:round/>
+                      <a:headEnd type="none" w="med" len="med"/>
+                      <a:tailEnd type="none" w="med" len="med"/>
+                    </a:lnT>
+                    <a:lnB w="9525" cap="flat" cmpd="sng" algn="ctr">
+                      <a:solidFill>
+                        <a:srgbClr val="BFC5CF"/>
+                      </a:solidFill>
+                      <a:prstDash val="solid"/>
+                      <a:round/>
+                      <a:headEnd type="none" w="med" len="med"/>
+                      <a:tailEnd type="none" w="med" len="med"/>
+                    </a:lnB>
+                  </a:tcPr>
+                </a:tc>
+              </a:tr>
+              <a:tr h="512064">
+                <a:tc>
+                  <a:txBody>
+                    <a:bodyPr/>
+                    <a:lstStyle/>
+                    <a:p>
+                      <a:pPr indent="0" marL="0">
+                        <a:buNone/>
+                      </a:pPr>
+                      <a:r>
+                        <a:rPr lang="en-US" sz="950" b="1" dirty="0">
+                          <a:solidFill>
+                            <a:srgbClr val="2F3E55"/>
+                          </a:solidFill>
+                          <a:latin typeface="맑은 고딕" pitchFamily="34" charset="0"/>
+                          <a:ea typeface="맑은 고딕" pitchFamily="34" charset="-122"/>
+                          <a:cs typeface="맑은 고딕" pitchFamily="34" charset="-120"/>
+                        </a:rPr>
+                        <a:t>5. 인력 전환을 핵심 과제로</a:t>
+                      </a:r>
+                      <a:endParaRPr lang="en-US" sz="900" dirty="0">
+                        <a:latin typeface="맑은 고딕" charset="0"/>
+                        <a:ea typeface="맑은 고딕" charset="0"/>
+                        <a:cs typeface="맑은 고딕" charset="0"/>
+                      </a:endParaRPr>
+                    </a:p>
+                    <a:p>
+                      <a:pPr indent="0" marL="0">
+                        <a:buNone/>
+                      </a:pPr>
+                      <a:r>
+                        <a:rPr lang="en-US" sz="800" dirty="0">
+                          <a:solidFill>
+                            <a:srgbClr val="5B6B82"/>
+                          </a:solidFill>
+                          <a:latin typeface="맑은 고딕" pitchFamily="34" charset="0"/>
+                          <a:ea typeface="맑은 고딕" pitchFamily="34" charset="-122"/>
+                          <a:cs typeface="맑은 고딕" pitchFamily="34" charset="-120"/>
+                        </a:rPr>
+                        <a:t>교육·직무 재설계·평가/보상 개편</a:t>
+                      </a:r>
+                      <a:endParaRPr lang="en-US" sz="900" dirty="0">
+                        <a:latin typeface="맑은 고딕" charset="0"/>
+                        <a:ea typeface="맑은 고딕" charset="0"/>
+                        <a:cs typeface="맑은 고딕" charset="0"/>
+                      </a:endParaRPr>
+                    </a:p>
+                  </a:txBody>
+                  <a:tcPr marL="45720" marR="45720" marT="18288" marB="18288" anchor="ctr">
+                    <a:lnL w="9525" cap="flat" cmpd="sng" algn="ctr">
+                      <a:solidFill>
+                        <a:srgbClr val="BFC5CF"/>
+                      </a:solidFill>
+                      <a:prstDash val="solid"/>
+                      <a:round/>
+                      <a:headEnd type="none" w="med" len="med"/>
+                      <a:tailEnd type="none" w="med" len="med"/>
+                    </a:lnL>
+                    <a:lnR w="9525" cap="flat" cmpd="sng" algn="ctr">
+                      <a:solidFill>
+                        <a:srgbClr val="BFC5CF"/>
+                      </a:solidFill>
+                      <a:prstDash val="solid"/>
+                      <a:round/>
+                      <a:headEnd type="none" w="med" len="med"/>
+                      <a:tailEnd type="none" w="med" len="med"/>
+                    </a:lnR>
+                    <a:lnT w="9525" cap="flat" cmpd="sng" algn="ctr">
+                      <a:solidFill>
+                        <a:srgbClr val="BFC5CF"/>
+                      </a:solidFill>
+                      <a:prstDash val="solid"/>
+                      <a:round/>
+                      <a:headEnd type="none" w="med" len="med"/>
+                      <a:tailEnd type="none" w="med" len="med"/>
+                    </a:lnT>
+                    <a:lnB w="9525" cap="flat" cmpd="sng" algn="ctr">
+                      <a:solidFill>
+                        <a:srgbClr val="BFC5CF"/>
+                      </a:solidFill>
+                      <a:prstDash val="solid"/>
+                      <a:round/>
+                      <a:headEnd type="none" w="med" len="med"/>
+                      <a:tailEnd type="none" w="med" len="med"/>
+                    </a:lnB>
+                  </a:tcPr>
+                </a:tc>
+                <a:tc>
+                  <a:txBody>
+                    <a:bodyPr/>
+                    <a:lstStyle/>
+                    <a:p>
+                      <a:pPr indent="0" marL="0">
+                        <a:buNone/>
+                      </a:pPr>
+                      <a:r>
+                        <a:rPr lang="en-US" sz="900" dirty="0">
+                          <a:solidFill>
+                            <a:srgbClr val="1F2329"/>
+                          </a:solidFill>
+                          <a:latin typeface="맑은 고딕" pitchFamily="34" charset="0"/>
+                          <a:ea typeface="맑은 고딕" pitchFamily="34" charset="-122"/>
+                          <a:cs typeface="맑은 고딕" pitchFamily="34" charset="-120"/>
+                        </a:rPr>
+                        <a:t>임원·실무 AI 실습교육, 직무 재설계는 PI와 연계 (평가·보상은 HR 협업)</a:t>
+                      </a:r>
+                      <a:endParaRPr lang="en-US" sz="900" dirty="0">
+                        <a:latin typeface="맑은 고딕" charset="0"/>
+                        <a:ea typeface="맑은 고딕" charset="0"/>
+                        <a:cs typeface="맑은 고딕" charset="0"/>
+                      </a:endParaRPr>
+                    </a:p>
+                  </a:txBody>
+                  <a:tcPr marL="45720" marR="45720" marT="18288" marB="18288" anchor="ctr">
+                    <a:lnL w="9525" cap="flat" cmpd="sng" algn="ctr">
+                      <a:solidFill>
+                        <a:srgbClr val="BFC5CF"/>
+                      </a:solidFill>
+                      <a:prstDash val="solid"/>
+                      <a:round/>
+                      <a:headEnd type="none" w="med" len="med"/>
+                      <a:tailEnd type="none" w="med" len="med"/>
+                    </a:lnL>
+                    <a:lnR w="9525" cap="flat" cmpd="sng" algn="ctr">
+                      <a:solidFill>
+                        <a:srgbClr val="BFC5CF"/>
+                      </a:solidFill>
+                      <a:prstDash val="solid"/>
+                      <a:round/>
+                      <a:headEnd type="none" w="med" len="med"/>
+                      <a:tailEnd type="none" w="med" len="med"/>
+                    </a:lnR>
+                    <a:lnT w="9525" cap="flat" cmpd="sng" algn="ctr">
+                      <a:solidFill>
+                        <a:srgbClr val="BFC5CF"/>
+                      </a:solidFill>
+                      <a:prstDash val="solid"/>
+                      <a:round/>
+                      <a:headEnd type="none" w="med" len="med"/>
+                      <a:tailEnd type="none" w="med" len="med"/>
+                    </a:lnT>
+                    <a:lnB w="9525" cap="flat" cmpd="sng" algn="ctr">
+                      <a:solidFill>
+                        <a:srgbClr val="BFC5CF"/>
+                      </a:solidFill>
+                      <a:prstDash val="solid"/>
+                      <a:round/>
+                      <a:headEnd type="none" w="med" len="med"/>
+                      <a:tailEnd type="none" w="med" len="med"/>
+                    </a:lnB>
+                  </a:tcPr>
+                </a:tc>
+                <a:tc>
+                  <a:txBody>
+                    <a:bodyPr/>
+                    <a:lstStyle/>
+                    <a:p>
+                      <a:pPr algn="ctr" indent="0" marL="0">
+                        <a:buNone/>
+                      </a:pPr>
+                      <a:r>
+                        <a:rPr lang="en-US" sz="900" b="1" dirty="0">
+                          <a:solidFill>
+                            <a:srgbClr val="1F2329"/>
+                          </a:solidFill>
+                          <a:latin typeface="맑은 고딕" pitchFamily="34" charset="0"/>
+                          <a:ea typeface="맑은 고딕" pitchFamily="34" charset="-122"/>
+                          <a:cs typeface="맑은 고딕" pitchFamily="34" charset="-120"/>
+                        </a:rPr>
+                        <a:t>AX·Biz</a:t>
+                      </a:r>
+                      <a:endParaRPr lang="en-US" sz="900" dirty="0">
+                        <a:latin typeface="맑은 고딕" charset="0"/>
+                        <a:ea typeface="맑은 고딕" charset="0"/>
+                        <a:cs typeface="맑은 고딕" charset="0"/>
+                      </a:endParaRPr>
+                    </a:p>
+                  </a:txBody>
+                  <a:tcPr marL="45720" marR="45720" marT="18288" marB="18288" anchor="ctr">
+                    <a:lnL w="9525" cap="flat" cmpd="sng" algn="ctr">
+                      <a:solidFill>
+                        <a:srgbClr val="BFC5CF"/>
+                      </a:solidFill>
+                      <a:prstDash val="solid"/>
+                      <a:round/>
+                      <a:headEnd type="none" w="med" len="med"/>
+                      <a:tailEnd type="none" w="med" len="med"/>
+                    </a:lnL>
+                    <a:lnR w="9525" cap="flat" cmpd="sng" algn="ctr">
+                      <a:solidFill>
+                        <a:srgbClr val="BFC5CF"/>
+                      </a:solidFill>
+                      <a:prstDash val="solid"/>
+                      <a:round/>
+                      <a:headEnd type="none" w="med" len="med"/>
+                      <a:tailEnd type="none" w="med" len="med"/>
+                    </a:lnR>
+                    <a:lnT w="9525" cap="flat" cmpd="sng" algn="ctr">
+                      <a:solidFill>
+                        <a:srgbClr val="BFC5CF"/>
+                      </a:solidFill>
+                      <a:prstDash val="solid"/>
+                      <a:round/>
+                      <a:headEnd type="none" w="med" len="med"/>
+                      <a:tailEnd type="none" w="med" len="med"/>
+                    </a:lnT>
+                    <a:lnB w="9525" cap="flat" cmpd="sng" algn="ctr">
+                      <a:solidFill>
+                        <a:srgbClr val="BFC5CF"/>
+                      </a:solidFill>
+                      <a:prstDash val="solid"/>
+                      <a:round/>
+                      <a:headEnd type="none" w="med" len="med"/>
+                      <a:tailEnd type="none" w="med" len="med"/>
+                    </a:lnB>
+                  </a:tcPr>
+                </a:tc>
+                <a:tc>
+                  <a:txBody>
+                    <a:bodyPr/>
+                    <a:lstStyle/>
+                    <a:p>
+                      <a:pPr algn="ctr" indent="0" marL="0">
+                        <a:buNone/>
+                      </a:pPr>
+                      <a:r>
+                        <a:rPr lang="en-US" sz="1300" dirty="0">
+                          <a:solidFill>
+                            <a:srgbClr val="1F4E9A"/>
+                          </a:solidFill>
+                          <a:latin typeface="맑은 고딕" pitchFamily="34" charset="0"/>
+                          <a:ea typeface="맑은 고딕" pitchFamily="34" charset="-122"/>
+                          <a:cs typeface="맑은 고딕" pitchFamily="34" charset="-120"/>
+                        </a:rPr>
+                        <a:t>◐</a:t>
+                      </a:r>
+                      <a:endParaRPr lang="en-US" sz="1300" dirty="0">
+                        <a:latin typeface="맑은 고딕" charset="0"/>
+                        <a:ea typeface="맑은 고딕" charset="0"/>
+                        <a:cs typeface="맑은 고딕" charset="0"/>
+                      </a:endParaRPr>
+                    </a:p>
+                  </a:txBody>
+                  <a:tcPr marL="45720" marR="45720" marT="18288" marB="18288" anchor="ctr">
+                    <a:lnL w="9525" cap="flat" cmpd="sng" algn="ctr">
+                      <a:solidFill>
+                        <a:srgbClr val="BFC5CF"/>
+                      </a:solidFill>
+                      <a:prstDash val="solid"/>
+                      <a:round/>
+                      <a:headEnd type="none" w="med" len="med"/>
+                      <a:tailEnd type="none" w="med" len="med"/>
+                    </a:lnL>
+                    <a:lnR w="9525" cap="flat" cmpd="sng" algn="ctr">
+                      <a:solidFill>
+                        <a:srgbClr val="BFC5CF"/>
+                      </a:solidFill>
+                      <a:prstDash val="solid"/>
+                      <a:round/>
+                      <a:headEnd type="none" w="med" len="med"/>
+                      <a:tailEnd type="none" w="med" len="med"/>
+                    </a:lnR>
+                    <a:lnT w="9525" cap="flat" cmpd="sng" algn="ctr">
+                      <a:solidFill>
+                        <a:srgbClr val="BFC5CF"/>
+                      </a:solidFill>
+                      <a:prstDash val="solid"/>
+                      <a:round/>
+                      <a:headEnd type="none" w="med" len="med"/>
+                      <a:tailEnd type="none" w="med" len="med"/>
+                    </a:lnT>
+                    <a:lnB w="9525" cap="flat" cmpd="sng" algn="ctr">
+                      <a:solidFill>
+                        <a:srgbClr val="BFC5CF"/>
+                      </a:solidFill>
+                      <a:prstDash val="solid"/>
+                      <a:round/>
+                      <a:headEnd type="none" w="med" len="med"/>
+                      <a:tailEnd type="none" w="med" len="med"/>
+                    </a:lnB>
+                  </a:tcPr>
+                </a:tc>
+              </a:tr>
+            </a:tbl>
+          </a:graphicData>
+        </a:graphic>
+      </p:graphicFrame>
+      <p:sp>
+        <p:nvSpPr>
+          <p:cNvPr id="11" name="Text 8"/>
+          <p:cNvSpPr txBox="1"/>
+          <p:nvPr/>
+        </p:nvSpPr>
+        <p:spPr>
+          <a:xfrm>
+            <a:off x="365760" y="5193792"/>
+            <a:ext cx="5532120" cy="201168"/>
+          </a:xfrm>
+          <a:prstGeom prst="rect">
+            <a:avLst/>
+          </a:prstGeom>
+          <a:noFill/>
+          <a:ln/>
+        </p:spPr>
+        <p:txBody>
+          <a:bodyPr wrap="square" lIns="0" tIns="0" rIns="0" bIns="0" rtlCol="0" anchor="ctr"/>
+          <a:lstStyle/>
+          <a:p>
+            <a:pPr algn="r" indent="0" marL="0">
+              <a:buNone/>
+            </a:pPr>
+            <a:r>
+              <a:rPr lang="en-US" sz="850" dirty="0">
+                <a:solidFill>
+                  <a:schemeClr val="accent5"/>
+                </a:solidFill>
+              </a:rPr>
+              <a:t>● 현 역량으로 충족   ◐ 엔지니어·유관부서 협업으로 보완</a:t>
+            </a:r>
+            <a:endParaRPr lang="en-US" sz="850" dirty="0"/>
+          </a:p>
+        </p:txBody>
+      </p:sp>
+      <p:sp>
+        <p:nvSpPr>
+          <p:cNvPr id="12" name="시사점 라벨"/>
+          <p:cNvSpPr txBox="1"/>
+          <p:nvPr/>
+        </p:nvSpPr>
+        <p:spPr>
+          <a:xfrm>
+            <a:off x="365760" y="5468112"/>
+            <a:ext cx="822960" cy="237744"/>
+          </a:xfrm>
+          <a:prstGeom prst="rect">
+            <a:avLst/>
+          </a:prstGeom>
+          <a:solidFill>
+            <a:schemeClr val="accent5"/>
+          </a:solidFill>
+          <a:ln/>
+        </p:spPr>
+        <p:txBody>
+          <a:bodyPr wrap="square" lIns="0" tIns="0" rIns="0" bIns="0" rtlCol="0" anchor="ctr"/>
+          <a:lstStyle/>
+          <a:p>
+            <a:pPr algn="ctr" indent="0" marL="0">
+              <a:buNone/>
+            </a:pPr>
+            <a:r>
+              <a:rPr lang="en-US" sz="1000" b="1" dirty="0">
+                <a:solidFill>
+                  <a:schemeClr val="bg1"/>
+                </a:solidFill>
+              </a:rPr>
+              <a:t>시사점</a:t>
+            </a:r>
+            <a:endParaRPr lang="en-US" sz="1000" dirty="0"/>
+          </a:p>
+        </p:txBody>
+      </p:sp>
+      <p:sp>
+        <p:nvSpPr>
+          <p:cNvPr id="13" name="시사점"/>
+          <p:cNvSpPr txBox="1"/>
+          <p:nvPr/>
+        </p:nvSpPr>
+        <p:spPr>
+          <a:xfrm>
+            <a:off x="365760" y="5733288"/>
+            <a:ext cx="5532120" cy="621792"/>
+          </a:xfrm>
+          <a:prstGeom prst="rect">
+            <a:avLst/>
+          </a:prstGeom>
+          <a:solidFill>
+            <a:schemeClr val="bg2"/>
+          </a:solidFill>
+          <a:ln/>
+        </p:spPr>
+        <p:txBody>
+          <a:bodyPr wrap="square" lIns="0" tIns="101600" rIns="101600" bIns="0" rtlCol="0" anchor="ctr"/>
+          <a:lstStyle/>
+          <a:p>
+            <a:pPr indent="0" marL="0">
+              <a:buNone/>
+            </a:pPr>
+            <a:r>
+              <a:rPr lang="en-US" sz="1050" b="1" dirty="0">
+                <a:solidFill>
+                  <a:schemeClr val="tx1"/>
+                </a:solidFill>
+              </a:rPr>
+              <a:t>성공조건 1·2는 AX·Biz컨설팅팀이 이미 보유한 강점</a:t>
+            </a:r>
+            <a:endParaRPr lang="en-US" sz="1050" dirty="0"/>
+          </a:p>
+          <a:p>
+            <a:pPr indent="0" marL="0">
+              <a:buNone/>
+            </a:pPr>
+            <a:r>
+              <a:rPr lang="en-US" sz="1050" b="1" dirty="0">
+                <a:solidFill>
+                  <a:srgbClr val="1F4E9A"/>
+                </a:solidFill>
+              </a:rPr>
+              <a:t>→ 3·4·5는 AI혁신센터·D&amp;AX부문·HR과의 FDE 협업 구조로 보완하면 충족 가능</a:t>
+            </a:r>
+            <a:endParaRPr lang="en-US" sz="1050" dirty="0"/>
+          </a:p>
+        </p:txBody>
+      </p:sp>
+      <p:sp>
+        <p:nvSpPr>
+          <p:cNvPr id="14" name="Text 11"/>
+          <p:cNvSpPr txBox="1"/>
+          <p:nvPr/>
+        </p:nvSpPr>
+        <p:spPr>
+          <a:xfrm>
+            <a:off x="6336792" y="2029968"/>
+            <a:ext cx="5532120" cy="256032"/>
+          </a:xfrm>
+          <a:prstGeom prst="rect">
+            <a:avLst/>
+          </a:prstGeom>
+          <a:noFill/>
+          <a:ln/>
+        </p:spPr>
+        <p:txBody>
+          <a:bodyPr wrap="square" lIns="0" tIns="0" rIns="0" bIns="0" rtlCol="0" anchor="ctr"/>
+          <a:lstStyle/>
+          <a:p>
+            <a:pPr indent="0" marL="0">
+              <a:buNone/>
+            </a:pPr>
+            <a:r>
+              <a:rPr lang="en-US" sz="1050" b="1" dirty="0">
+                <a:solidFill>
+                  <a:schemeClr val="accent5"/>
+                </a:solidFill>
+              </a:rPr>
+              <a:t>※ 주요 컨설팅사 AX 추진방안 6단계와 담당 역량</a:t>
+            </a:r>
+            <a:endParaRPr lang="en-US" sz="1050" dirty="0"/>
+          </a:p>
+        </p:txBody>
+      </p:sp>
+      <p:sp>
+        <p:nvSpPr>
+          <p:cNvPr id="15" name="단계 1"/>
+          <p:cNvSpPr/>
+          <p:nvPr/>
+        </p:nvSpPr>
+        <p:spPr>
+          <a:xfrm>
+            <a:off x="6336792" y="2359152"/>
+            <a:ext cx="1810512" cy="420624"/>
+          </a:xfrm>
+          <a:prstGeom prst="homePlate">
+            <a:avLst/>
+          </a:prstGeom>
+          <a:solidFill>
+            <a:srgbClr val="5B7FB8"/>
+          </a:solidFill>
+          <a:ln/>
+        </p:spPr>
+        <p:txBody>
+          <a:bodyPr wrap="square" lIns="0" tIns="0" rIns="0" bIns="0" rtlCol="0" anchor="ctr"/>
+          <a:lstStyle/>
+          <a:p>
+            <a:pPr algn="ctr" indent="0" marL="0">
+              <a:buNone/>
+            </a:pPr>
+            <a:r>
+              <a:rPr lang="en-US" sz="900" b="1" dirty="0">
+                <a:solidFill>
+                  <a:schemeClr val="bg1"/>
+                </a:solidFill>
+              </a:rPr>
+              <a:t>1. 전략적 가치영역 선정</a:t>
+            </a:r>
+            <a:endParaRPr lang="en-US" sz="900" dirty="0"/>
+          </a:p>
+        </p:txBody>
+      </p:sp>
+      <p:sp>
+        <p:nvSpPr>
+          <p:cNvPr id="16" name="담당 1"/>
+          <p:cNvSpPr txBox="1"/>
+          <p:nvPr/>
+        </p:nvSpPr>
+        <p:spPr>
+          <a:xfrm>
+            <a:off x="6473952" y="2825496"/>
+            <a:ext cx="1490472" cy="402336"/>
+          </a:xfrm>
+          <a:prstGeom prst="rect">
+            <a:avLst/>
+          </a:prstGeom>
+          <a:solidFill>
+            <a:schemeClr val="bg2"/>
+          </a:solidFill>
+          <a:ln/>
+        </p:spPr>
+        <p:txBody>
+          <a:bodyPr wrap="square" lIns="0" tIns="0" rIns="0" bIns="0" rtlCol="0" anchor="ctr"/>
+          <a:lstStyle/>
+          <a:p>
+            <a:pPr algn="ctr" indent="0" marL="0">
+              <a:buNone/>
+            </a:pPr>
+            <a:r>
+              <a:rPr lang="en-US" sz="850" b="1" dirty="0">
+                <a:solidFill>
+                  <a:schemeClr val="tx2"/>
+                </a:solidFill>
+              </a:rPr>
+              <a:t>Biz·AX</a:t>
+            </a:r>
+            <a:endParaRPr lang="en-US" sz="850" dirty="0"/>
+          </a:p>
+          <a:p>
+            <a:pPr algn="ctr" indent="0" marL="0">
+              <a:buNone/>
+            </a:pPr>
+            <a:r>
+              <a:rPr lang="en-US" sz="850" b="1" dirty="0">
+                <a:solidFill>
+                  <a:schemeClr val="tx2"/>
+                </a:solidFill>
+              </a:rPr>
+              <a:t>(과제 Pool 108)</a:t>
+            </a:r>
+            <a:endParaRPr lang="en-US" sz="850" dirty="0"/>
+          </a:p>
+        </p:txBody>
+      </p:sp>
+      <p:sp>
+        <p:nvSpPr>
+          <p:cNvPr id="17" name="단계 2"/>
+          <p:cNvSpPr/>
+          <p:nvPr/>
+        </p:nvSpPr>
+        <p:spPr>
+          <a:xfrm>
+            <a:off x="8183880" y="2359152"/>
+            <a:ext cx="1810512" cy="420624"/>
+          </a:xfrm>
+          <a:prstGeom prst="chevron">
+            <a:avLst/>
+          </a:prstGeom>
+          <a:solidFill>
+            <a:srgbClr val="5B7FB8"/>
+          </a:solidFill>
+          <a:ln/>
+        </p:spPr>
+        <p:txBody>
+          <a:bodyPr wrap="square" lIns="0" tIns="0" rIns="0" bIns="0" rtlCol="0" anchor="ctr"/>
+          <a:lstStyle/>
+          <a:p>
+            <a:pPr algn="ctr" indent="0" marL="0">
+              <a:buNone/>
+            </a:pPr>
+            <a:r>
+              <a:rPr lang="en-US" sz="900" b="1" dirty="0">
+                <a:solidFill>
+                  <a:schemeClr val="bg1"/>
+                </a:solidFill>
+              </a:rPr>
+              <a:t>2. 핵심 유스케이스 실행</a:t>
+            </a:r>
+            <a:endParaRPr lang="en-US" sz="900" dirty="0"/>
+          </a:p>
+        </p:txBody>
+      </p:sp>
+      <p:sp>
+        <p:nvSpPr>
+          <p:cNvPr id="18" name="담당 2"/>
+          <p:cNvSpPr txBox="1"/>
+          <p:nvPr/>
+        </p:nvSpPr>
+        <p:spPr>
+          <a:xfrm>
+            <a:off x="8321040" y="2825496"/>
+            <a:ext cx="1490472" cy="402336"/>
+          </a:xfrm>
+          <a:prstGeom prst="rect">
+            <a:avLst/>
+          </a:prstGeom>
+          <a:solidFill>
+            <a:schemeClr val="bg2"/>
+          </a:solidFill>
+          <a:ln/>
+        </p:spPr>
+        <p:txBody>
+          <a:bodyPr wrap="square" lIns="0" tIns="0" rIns="0" bIns="0" rtlCol="0" anchor="ctr"/>
+          <a:lstStyle/>
+          <a:p>
+            <a:pPr algn="ctr" indent="0" marL="0">
+              <a:buNone/>
+            </a:pPr>
+            <a:r>
+              <a:rPr lang="en-US" sz="850" b="1" dirty="0">
+                <a:solidFill>
+                  <a:schemeClr val="tx2"/>
+                </a:solidFill>
+              </a:rPr>
+              <a:t>FDE 공동 TF</a:t>
+            </a:r>
+            <a:endParaRPr lang="en-US" sz="850" dirty="0"/>
+          </a:p>
+          <a:p>
+            <a:pPr algn="ctr" indent="0" marL="0">
+              <a:buNone/>
+            </a:pPr>
+            <a:r>
+              <a:rPr lang="en-US" sz="850" b="1" dirty="0">
+                <a:solidFill>
+                  <a:schemeClr val="tx2"/>
+                </a:solidFill>
+              </a:rPr>
+              <a:t>(MVP)</a:t>
+            </a:r>
+            <a:endParaRPr lang="en-US" sz="850" dirty="0"/>
+          </a:p>
+        </p:txBody>
+      </p:sp>
+      <p:sp>
+        <p:nvSpPr>
+          <p:cNvPr id="19" name="단계 3"/>
+          <p:cNvSpPr/>
+          <p:nvPr/>
+        </p:nvSpPr>
+        <p:spPr>
+          <a:xfrm>
+            <a:off x="10030968" y="2359152"/>
+            <a:ext cx="1810512" cy="420624"/>
+          </a:xfrm>
+          <a:prstGeom prst="chevron">
+            <a:avLst/>
+          </a:prstGeom>
+          <a:solidFill>
+            <a:srgbClr val="5B7FB8"/>
+          </a:solidFill>
+          <a:ln/>
+        </p:spPr>
+        <p:txBody>
+          <a:bodyPr wrap="square" lIns="0" tIns="0" rIns="0" bIns="0" rtlCol="0" anchor="ctr"/>
+          <a:lstStyle/>
+          <a:p>
+            <a:pPr algn="ctr" indent="0" marL="0">
+              <a:buNone/>
+            </a:pPr>
+            <a:r>
+              <a:rPr lang="en-US" sz="900" b="1" dirty="0">
+                <a:solidFill>
+                  <a:schemeClr val="bg1"/>
+                </a:solidFill>
+              </a:rPr>
+              <a:t>3. 데이터·AI 플랫폼 구축</a:t>
+            </a:r>
+            <a:endParaRPr lang="en-US" sz="900" dirty="0"/>
+          </a:p>
+        </p:txBody>
+      </p:sp>
+      <p:sp>
+        <p:nvSpPr>
+          <p:cNvPr id="20" name="담당 3"/>
+          <p:cNvSpPr txBox="1"/>
+          <p:nvPr/>
+        </p:nvSpPr>
+        <p:spPr>
+          <a:xfrm>
+            <a:off x="10168128" y="2825496"/>
+            <a:ext cx="1490472" cy="402336"/>
+          </a:xfrm>
+          <a:prstGeom prst="rect">
+            <a:avLst/>
+          </a:prstGeom>
+          <a:solidFill>
+            <a:schemeClr val="bg2"/>
+          </a:solidFill>
+          <a:ln/>
+        </p:spPr>
+        <p:txBody>
+          <a:bodyPr wrap="square" lIns="0" tIns="0" rIns="0" bIns="0" rtlCol="0" anchor="ctr"/>
+          <a:lstStyle/>
+          <a:p>
+            <a:pPr algn="ctr" indent="0" marL="0">
+              <a:buNone/>
+            </a:pPr>
+            <a:r>
+              <a:rPr lang="en-US" sz="850" b="1" dirty="0">
+                <a:solidFill>
+                  <a:schemeClr val="tx2"/>
+                </a:solidFill>
+              </a:rPr>
+              <a:t>AI혁신센터</a:t>
+            </a:r>
+            <a:endParaRPr lang="en-US" sz="850" dirty="0"/>
+          </a:p>
+          <a:p>
+            <a:pPr algn="ctr" indent="0" marL="0">
+              <a:buNone/>
+            </a:pPr>
+            <a:r>
+              <a:rPr lang="en-US" sz="850" b="1" dirty="0">
+                <a:solidFill>
+                  <a:schemeClr val="tx2"/>
+                </a:solidFill>
+              </a:rPr>
+              <a:t>D&amp;AX부문</a:t>
+            </a:r>
+            <a:endParaRPr lang="en-US" sz="850" dirty="0"/>
+          </a:p>
+        </p:txBody>
+      </p:sp>
+      <p:sp>
+        <p:nvSpPr>
+          <p:cNvPr id="21" name="단계 4"/>
+          <p:cNvSpPr/>
+          <p:nvPr/>
+        </p:nvSpPr>
+        <p:spPr>
+          <a:xfrm>
+            <a:off x="6336792" y="3346704"/>
+            <a:ext cx="1810512" cy="420624"/>
+          </a:xfrm>
+          <a:prstGeom prst="homePlate">
+            <a:avLst/>
+          </a:prstGeom>
+          <a:solidFill>
+            <a:schemeClr val="accent1"/>
+          </a:solidFill>
+          <a:ln/>
+        </p:spPr>
+        <p:txBody>
+          <a:bodyPr wrap="square" lIns="0" tIns="0" rIns="0" bIns="0" rtlCol="0" anchor="ctr"/>
+          <a:lstStyle/>
+          <a:p>
+            <a:pPr algn="ctr" indent="0" marL="0">
+              <a:buNone/>
+            </a:pPr>
+            <a:r>
+              <a:rPr lang="en-US" sz="900" b="1" dirty="0">
+                <a:solidFill>
+                  <a:schemeClr val="bg1"/>
+                </a:solidFill>
+              </a:rPr>
+              <a:t>4. 업무·조직 재설계</a:t>
+            </a:r>
+            <a:endParaRPr lang="en-US" sz="900" dirty="0"/>
+          </a:p>
+        </p:txBody>
+      </p:sp>
+      <p:sp>
+        <p:nvSpPr>
+          <p:cNvPr id="22" name="담당 4"/>
+          <p:cNvSpPr txBox="1"/>
+          <p:nvPr/>
+        </p:nvSpPr>
+        <p:spPr>
+          <a:xfrm>
+            <a:off x="6473952" y="3813048"/>
+            <a:ext cx="1490472" cy="402336"/>
+          </a:xfrm>
+          <a:prstGeom prst="rect">
+            <a:avLst/>
+          </a:prstGeom>
+          <a:solidFill>
+            <a:schemeClr val="bg2"/>
+          </a:solidFill>
+          <a:ln/>
+        </p:spPr>
+        <p:txBody>
+          <a:bodyPr wrap="square" lIns="0" tIns="0" rIns="0" bIns="0" rtlCol="0" anchor="ctr"/>
+          <a:lstStyle/>
+          <a:p>
+            <a:pPr algn="ctr" indent="0" marL="0">
+              <a:buNone/>
+            </a:pPr>
+            <a:r>
+              <a:rPr lang="en-US" sz="850" b="1" dirty="0">
+                <a:solidFill>
+                  <a:schemeClr val="tx2"/>
+                </a:solidFill>
+              </a:rPr>
+              <a:t>Biz컨설팅팀</a:t>
+            </a:r>
+            <a:endParaRPr lang="en-US" sz="850" dirty="0"/>
+          </a:p>
+          <a:p>
+            <a:pPr algn="ctr" indent="0" marL="0">
+              <a:buNone/>
+            </a:pPr>
+            <a:r>
+              <a:rPr lang="en-US" sz="850" b="1" dirty="0">
+                <a:solidFill>
+                  <a:schemeClr val="tx2"/>
+                </a:solidFill>
+              </a:rPr>
+              <a:t>(PI/ISP)</a:t>
+            </a:r>
+            <a:endParaRPr lang="en-US" sz="850" dirty="0"/>
+          </a:p>
+        </p:txBody>
+      </p:sp>
+      <p:sp>
+        <p:nvSpPr>
+          <p:cNvPr id="23" name="단계 5"/>
+          <p:cNvSpPr/>
+          <p:nvPr/>
+        </p:nvSpPr>
+        <p:spPr>
+          <a:xfrm>
+            <a:off x="8183880" y="3346704"/>
+            <a:ext cx="1810512" cy="420624"/>
+          </a:xfrm>
+          <a:prstGeom prst="chevron">
+            <a:avLst/>
+          </a:prstGeom>
+          <a:solidFill>
+            <a:schemeClr val="accent1"/>
+          </a:solidFill>
+          <a:ln/>
+        </p:spPr>
+        <p:txBody>
+          <a:bodyPr wrap="square" lIns="0" tIns="0" rIns="0" bIns="0" rtlCol="0" anchor="ctr"/>
+          <a:lstStyle/>
+          <a:p>
+            <a:pPr algn="ctr" indent="0" marL="0">
+              <a:buNone/>
+            </a:pPr>
+            <a:r>
+              <a:rPr lang="en-US" sz="900" b="1" dirty="0">
+                <a:solidFill>
+                  <a:schemeClr val="bg1"/>
+                </a:solidFill>
+              </a:rPr>
+              <a:t>5. 거버넌스 내재화</a:t>
+            </a:r>
+            <a:endParaRPr lang="en-US" sz="900" dirty="0"/>
+          </a:p>
+        </p:txBody>
+      </p:sp>
+      <p:sp>
+        <p:nvSpPr>
+          <p:cNvPr id="24" name="담당 5"/>
+          <p:cNvSpPr txBox="1"/>
+          <p:nvPr/>
+        </p:nvSpPr>
+        <p:spPr>
+          <a:xfrm>
+            <a:off x="8321040" y="3813048"/>
+            <a:ext cx="1490472" cy="402336"/>
+          </a:xfrm>
+          <a:prstGeom prst="rect">
+            <a:avLst/>
+          </a:prstGeom>
+          <a:solidFill>
+            <a:schemeClr val="bg2"/>
+          </a:solidFill>
+          <a:ln/>
+        </p:spPr>
+        <p:txBody>
+          <a:bodyPr wrap="square" lIns="0" tIns="0" rIns="0" bIns="0" rtlCol="0" anchor="ctr"/>
+          <a:lstStyle/>
+          <a:p>
+            <a:pPr algn="ctr" indent="0" marL="0">
+              <a:buNone/>
+            </a:pPr>
+            <a:r>
+              <a:rPr lang="en-US" sz="850" b="1" dirty="0">
+                <a:solidFill>
+                  <a:schemeClr val="tx2"/>
+                </a:solidFill>
+              </a:rPr>
+              <a:t>FDE 협의체</a:t>
+            </a:r>
+            <a:endParaRPr lang="en-US" sz="850" dirty="0"/>
+          </a:p>
+          <a:p>
+            <a:pPr algn="ctr" indent="0" marL="0">
+              <a:buNone/>
+            </a:pPr>
+            <a:r>
+              <a:rPr lang="en-US" sz="850" b="1" dirty="0">
+                <a:solidFill>
+                  <a:schemeClr val="tx2"/>
+                </a:solidFill>
+              </a:rPr>
+              <a:t>(성과관리)</a:t>
+            </a:r>
+            <a:endParaRPr lang="en-US" sz="850" dirty="0"/>
+          </a:p>
+        </p:txBody>
+      </p:sp>
+      <p:sp>
+        <p:nvSpPr>
+          <p:cNvPr id="25" name="단계 6"/>
+          <p:cNvSpPr/>
+          <p:nvPr/>
+        </p:nvSpPr>
+        <p:spPr>
+          <a:xfrm>
+            <a:off x="10030968" y="3346704"/>
+            <a:ext cx="1810512" cy="420624"/>
+          </a:xfrm>
+          <a:prstGeom prst="chevron">
+            <a:avLst/>
+          </a:prstGeom>
+          <a:solidFill>
+            <a:schemeClr val="accent1"/>
+          </a:solidFill>
+          <a:ln/>
+        </p:spPr>
+        <p:txBody>
+          <a:bodyPr wrap="square" lIns="0" tIns="0" rIns="0" bIns="0" rtlCol="0" anchor="ctr"/>
+          <a:lstStyle/>
+          <a:p>
+            <a:pPr algn="ctr" indent="0" marL="0">
+              <a:buNone/>
+            </a:pPr>
+            <a:r>
+              <a:rPr lang="en-US" sz="900" b="1" dirty="0">
+                <a:solidFill>
+                  <a:schemeClr val="bg1"/>
+                </a:solidFill>
+              </a:rPr>
+              <a:t>6. AI 에이전트 기반</a:t>
+            </a:r>
+            <a:endParaRPr lang="en-US" sz="900" dirty="0"/>
+          </a:p>
+          <a:p>
+            <a:pPr algn="ctr" indent="0" marL="0">
+              <a:buNone/>
+            </a:pPr>
+            <a:r>
+              <a:rPr lang="en-US" sz="900" b="1" dirty="0">
+                <a:solidFill>
+                  <a:schemeClr val="bg1"/>
+                </a:solidFill>
+              </a:rPr>
+              <a:t>전사 운영모델</a:t>
+            </a:r>
+            <a:endParaRPr lang="en-US" sz="900" dirty="0"/>
+          </a:p>
+        </p:txBody>
+      </p:sp>
+      <p:sp>
+        <p:nvSpPr>
+          <p:cNvPr id="26" name="담당 6"/>
+          <p:cNvSpPr txBox="1"/>
+          <p:nvPr/>
+        </p:nvSpPr>
+        <p:spPr>
+          <a:xfrm>
+            <a:off x="10168128" y="3813048"/>
+            <a:ext cx="1490472" cy="402336"/>
+          </a:xfrm>
+          <a:prstGeom prst="rect">
+            <a:avLst/>
+          </a:prstGeom>
+          <a:solidFill>
+            <a:schemeClr val="bg2"/>
+          </a:solidFill>
+          <a:ln/>
+        </p:spPr>
+        <p:txBody>
+          <a:bodyPr wrap="square" lIns="0" tIns="0" rIns="0" bIns="0" rtlCol="0" anchor="ctr"/>
+          <a:lstStyle/>
+          <a:p>
+            <a:pPr algn="ctr" indent="0" marL="0">
+              <a:buNone/>
+            </a:pPr>
+            <a:r>
+              <a:rPr lang="en-US" sz="850" b="1" dirty="0">
+                <a:solidFill>
+                  <a:schemeClr val="tx2"/>
+                </a:solidFill>
+              </a:rPr>
+              <a:t>AX 플랫폼</a:t>
+            </a:r>
+            <a:endParaRPr lang="en-US" sz="850" dirty="0"/>
+          </a:p>
+          <a:p>
+            <a:pPr algn="ctr" indent="0" marL="0">
+              <a:buNone/>
+            </a:pPr>
+            <a:r>
+              <a:rPr lang="en-US" sz="850" b="1" dirty="0">
+                <a:solidFill>
+                  <a:schemeClr val="tx2"/>
+                </a:solidFill>
+              </a:rPr>
+              <a:t>('30 Consulting OS)</a:t>
+            </a:r>
+            <a:endParaRPr lang="en-US" sz="850" dirty="0"/>
+          </a:p>
+        </p:txBody>
+      </p:sp>
+      <p:sp>
+        <p:nvSpPr>
+          <p:cNvPr id="27" name="Text 24"/>
+          <p:cNvSpPr txBox="1"/>
+          <p:nvPr/>
+        </p:nvSpPr>
+        <p:spPr>
+          <a:xfrm>
+            <a:off x="6336792" y="4370832"/>
+            <a:ext cx="5532120" cy="256032"/>
+          </a:xfrm>
+          <a:prstGeom prst="rect">
+            <a:avLst/>
+          </a:prstGeom>
+          <a:noFill/>
+          <a:ln/>
+        </p:spPr>
+        <p:txBody>
+          <a:bodyPr wrap="square" lIns="0" tIns="0" rIns="0" bIns="0" rtlCol="0" anchor="ctr"/>
+          <a:lstStyle/>
+          <a:p>
+            <a:pPr indent="0" marL="0">
+              <a:buNone/>
+            </a:pPr>
+            <a:r>
+              <a:rPr lang="en-US" sz="1050" b="1" dirty="0">
+                <a:solidFill>
+                  <a:schemeClr val="accent5"/>
+                </a:solidFill>
+              </a:rPr>
+              <a:t>※ 대기업형 혼합 AX 모델 : 그룹 내부 역량 매핑</a:t>
+            </a:r>
+            <a:endParaRPr lang="en-US" sz="1050" dirty="0"/>
+          </a:p>
+        </p:txBody>
+      </p:sp>
+      <p:graphicFrame>
+        <p:nvGraphicFramePr>
+          <p:cNvPr id="5" name="혼합 모델 표"/>
+          <p:cNvGraphicFramePr>
+            <a:graphicFrameLocks noGrp="1"/>
+          </p:cNvGraphicFramePr>
+          <p:nvPr>
+            <p:extLst>
+              <p:ext uri="{D42A27DB-BD31-4B8C-83A1-F6EECF244321}">
+                <p14:modId xmlns:p14="http://schemas.microsoft.com/office/powerpoint/2010/main" val="1579011935"/>
+              </p:ext>
+            </p:extLst>
+          </p:nvPr>
+        </p:nvGraphicFramePr>
+        <p:xfrm>
+          <a:off x="6291072" y="4663440"/>
+          <a:ext cx="5532120" cy="914400"/>
+        </p:xfrm>
+        <a:graphic>
+          <a:graphicData uri="http://schemas.openxmlformats.org/drawingml/2006/table">
+            <a:tbl>
+              <a:tblPr/>
+              <a:tblGrid>
+                <a:gridCol w="1325880"/>
+                <a:gridCol w="1280160"/>
+                <a:gridCol w="2926080"/>
+              </a:tblGrid>
+              <a:tr h="237744">
+                <a:tc>
+                  <a:txBody>
+                    <a:bodyPr/>
+                    <a:lstStyle/>
+                    <a:p>
+                      <a:pPr algn="ctr" indent="0" marL="0">
+                        <a:buNone/>
+                      </a:pPr>
+                      <a:r>
+                        <a:rPr lang="en-US" sz="950" b="1" dirty="0">
+                          <a:solidFill>
+                            <a:srgbClr val="1F2329"/>
+                          </a:solidFill>
+                          <a:latin typeface="맑은 고딕" pitchFamily="34" charset="0"/>
+                          <a:ea typeface="맑은 고딕" pitchFamily="34" charset="-122"/>
+                          <a:cs typeface="맑은 고딕" pitchFamily="34" charset="-120"/>
+                        </a:rPr>
+                        <a:t>모델 유형</a:t>
+                      </a:r>
+                      <a:endParaRPr lang="en-US" sz="950" dirty="0">
+                        <a:latin typeface="맑은 고딕" charset="0"/>
+                        <a:ea typeface="맑은 고딕" charset="0"/>
+                        <a:cs typeface="맑은 고딕" charset="0"/>
+                      </a:endParaRPr>
+                    </a:p>
+                  </a:txBody>
+                  <a:tcPr marL="45720" marR="45720" marT="18288" marB="18288" anchor="ctr">
+                    <a:lnL w="9525" cap="flat" cmpd="sng" algn="ctr">
+                      <a:solidFill>
+                        <a:srgbClr val="BFC5CF"/>
+                      </a:solidFill>
+                      <a:prstDash val="solid"/>
+                      <a:round/>
+                      <a:headEnd type="none" w="med" len="med"/>
+                      <a:tailEnd type="none" w="med" len="med"/>
+                    </a:lnL>
+                    <a:lnR w="9525" cap="flat" cmpd="sng" algn="ctr">
+                      <a:solidFill>
+                        <a:srgbClr val="BFC5CF"/>
+                      </a:solidFill>
+                      <a:prstDash val="solid"/>
+                      <a:round/>
+                      <a:headEnd type="none" w="med" len="med"/>
+                      <a:tailEnd type="none" w="med" len="med"/>
+                    </a:lnR>
+                    <a:lnT w="9525" cap="flat" cmpd="sng" algn="ctr">
+                      <a:solidFill>
+                        <a:srgbClr val="BFC5CF"/>
+                      </a:solidFill>
+                      <a:prstDash val="solid"/>
+                      <a:round/>
+                      <a:headEnd type="none" w="med" len="med"/>
+                      <a:tailEnd type="none" w="med" len="med"/>
+                    </a:lnT>
+                    <a:lnB w="9525" cap="flat" cmpd="sng" algn="ctr">
+                      <a:solidFill>
+                        <a:srgbClr val="BFC5CF"/>
+                      </a:solidFill>
+                      <a:prstDash val="solid"/>
+                      <a:round/>
+                      <a:headEnd type="none" w="med" len="med"/>
+                      <a:tailEnd type="none" w="med" len="med"/>
+                    </a:lnB>
+                    <a:solidFill>
+                      <a:srgbClr val="D9DDE3"/>
+                    </a:solidFill>
+                  </a:tcPr>
+                </a:tc>
+                <a:tc>
+                  <a:txBody>
+                    <a:bodyPr/>
+                    <a:lstStyle/>
+                    <a:p>
+                      <a:pPr algn="ctr" indent="0" marL="0">
+                        <a:buNone/>
+                      </a:pPr>
+                      <a:r>
+                        <a:rPr lang="en-US" sz="950" b="1" dirty="0">
+                          <a:solidFill>
+                            <a:srgbClr val="1F2329"/>
+                          </a:solidFill>
+                          <a:latin typeface="맑은 고딕" pitchFamily="34" charset="0"/>
+                          <a:ea typeface="맑은 고딕" pitchFamily="34" charset="-122"/>
+                          <a:cs typeface="맑은 고딕" pitchFamily="34" charset="-120"/>
+                        </a:rPr>
+                        <a:t>핵심 강점</a:t>
+                      </a:r>
+                      <a:endParaRPr lang="en-US" sz="950" dirty="0">
+                        <a:latin typeface="맑은 고딕" charset="0"/>
+                        <a:ea typeface="맑은 고딕" charset="0"/>
+                        <a:cs typeface="맑은 고딕" charset="0"/>
+                      </a:endParaRPr>
+                    </a:p>
+                  </a:txBody>
+                  <a:tcPr marL="45720" marR="45720" marT="18288" marB="18288" anchor="ctr">
+                    <a:lnL w="9525" cap="flat" cmpd="sng" algn="ctr">
+                      <a:solidFill>
+                        <a:srgbClr val="BFC5CF"/>
+                      </a:solidFill>
+                      <a:prstDash val="solid"/>
+                      <a:round/>
+                      <a:headEnd type="none" w="med" len="med"/>
+                      <a:tailEnd type="none" w="med" len="med"/>
+                    </a:lnL>
+                    <a:lnR w="9525" cap="flat" cmpd="sng" algn="ctr">
+                      <a:solidFill>
+                        <a:srgbClr val="BFC5CF"/>
+                      </a:solidFill>
+                      <a:prstDash val="solid"/>
+                      <a:round/>
+                      <a:headEnd type="none" w="med" len="med"/>
+                      <a:tailEnd type="none" w="med" len="med"/>
+                    </a:lnR>
+                    <a:lnT w="9525" cap="flat" cmpd="sng" algn="ctr">
+                      <a:solidFill>
+                        <a:srgbClr val="BFC5CF"/>
+                      </a:solidFill>
+                      <a:prstDash val="solid"/>
+                      <a:round/>
+                      <a:headEnd type="none" w="med" len="med"/>
+                      <a:tailEnd type="none" w="med" len="med"/>
+                    </a:lnT>
+                    <a:lnB w="9525" cap="flat" cmpd="sng" algn="ctr">
+                      <a:solidFill>
+                        <a:srgbClr val="BFC5CF"/>
+                      </a:solidFill>
+                      <a:prstDash val="solid"/>
+                      <a:round/>
+                      <a:headEnd type="none" w="med" len="med"/>
+                      <a:tailEnd type="none" w="med" len="med"/>
+                    </a:lnB>
+                    <a:solidFill>
+                      <a:srgbClr val="D9DDE3"/>
+                    </a:solidFill>
+                  </a:tcPr>
+                </a:tc>
+                <a:tc>
+                  <a:txBody>
+                    <a:bodyPr/>
+                    <a:lstStyle/>
+                    <a:p>
+                      <a:pPr algn="ctr" indent="0" marL="0">
+                        <a:buNone/>
+                      </a:pPr>
+                      <a:r>
+                        <a:rPr lang="en-US" sz="950" b="1" dirty="0">
+                          <a:solidFill>
+                            <a:srgbClr val="1F2329"/>
+                          </a:solidFill>
+                          <a:latin typeface="맑은 고딕" pitchFamily="34" charset="0"/>
+                          <a:ea typeface="맑은 고딕" pitchFamily="34" charset="-122"/>
+                          <a:cs typeface="맑은 고딕" pitchFamily="34" charset="-120"/>
+                        </a:rPr>
+                        <a:t>그룹 내 대응 역량</a:t>
+                      </a:r>
+                      <a:endParaRPr lang="en-US" sz="950" dirty="0">
+                        <a:latin typeface="맑은 고딕" charset="0"/>
+                        <a:ea typeface="맑은 고딕" charset="0"/>
+                        <a:cs typeface="맑은 고딕" charset="0"/>
+                      </a:endParaRPr>
+                    </a:p>
+                  </a:txBody>
+                  <a:tcPr marL="45720" marR="45720" marT="18288" marB="18288" anchor="ctr">
+                    <a:lnL w="9525" cap="flat" cmpd="sng" algn="ctr">
+                      <a:solidFill>
+                        <a:srgbClr val="BFC5CF"/>
+                      </a:solidFill>
+                      <a:prstDash val="solid"/>
+                      <a:round/>
+                      <a:headEnd type="none" w="med" len="med"/>
+                      <a:tailEnd type="none" w="med" len="med"/>
+                    </a:lnL>
+                    <a:lnR w="9525" cap="flat" cmpd="sng" algn="ctr">
+                      <a:solidFill>
+                        <a:srgbClr val="BFC5CF"/>
+                      </a:solidFill>
+                      <a:prstDash val="solid"/>
+                      <a:round/>
+                      <a:headEnd type="none" w="med" len="med"/>
+                      <a:tailEnd type="none" w="med" len="med"/>
+                    </a:lnR>
+                    <a:lnT w="9525" cap="flat" cmpd="sng" algn="ctr">
+                      <a:solidFill>
+                        <a:srgbClr val="BFC5CF"/>
+                      </a:solidFill>
+                      <a:prstDash val="solid"/>
+                      <a:round/>
+                      <a:headEnd type="none" w="med" len="med"/>
+                      <a:tailEnd type="none" w="med" len="med"/>
+                    </a:lnT>
+                    <a:lnB w="9525" cap="flat" cmpd="sng" algn="ctr">
+                      <a:solidFill>
+                        <a:srgbClr val="BFC5CF"/>
+                      </a:solidFill>
+                      <a:prstDash val="solid"/>
+                      <a:round/>
+                      <a:headEnd type="none" w="med" len="med"/>
+                      <a:tailEnd type="none" w="med" len="med"/>
+                    </a:lnB>
+                    <a:solidFill>
+                      <a:srgbClr val="D9DDE3"/>
+                    </a:solidFill>
+                  </a:tcPr>
+                </a:tc>
+              </a:tr>
+              <a:tr h="237744">
+                <a:tc>
+                  <a:txBody>
+                    <a:bodyPr/>
+                    <a:lstStyle/>
+                    <a:p>
+                      <a:pPr algn="ctr" indent="0" marL="0">
+                        <a:buNone/>
+                      </a:pPr>
+                      <a:r>
+                        <a:rPr lang="en-US" sz="900" b="1" dirty="0">
+                          <a:solidFill>
+                            <a:srgbClr val="1F2329"/>
+                          </a:solidFill>
+                          <a:latin typeface="맑은 고딕" pitchFamily="34" charset="0"/>
+                          <a:ea typeface="맑은 고딕" pitchFamily="34" charset="-122"/>
+                          <a:cs typeface="맑은 고딕" pitchFamily="34" charset="-120"/>
+                        </a:rPr>
+                        <a:t>Accenture·IBM식</a:t>
+                      </a:r>
+                      <a:endParaRPr lang="en-US" sz="900" dirty="0">
+                        <a:latin typeface="맑은 고딕" charset="0"/>
+                        <a:ea typeface="맑은 고딕" charset="0"/>
+                        <a:cs typeface="맑은 고딕" charset="0"/>
+                      </a:endParaRPr>
+                    </a:p>
+                  </a:txBody>
+                  <a:tcPr marL="45720" marR="45720" marT="18288" marB="18288" anchor="ctr">
+                    <a:lnL w="9525" cap="flat" cmpd="sng" algn="ctr">
+                      <a:solidFill>
+                        <a:srgbClr val="BFC5CF"/>
+                      </a:solidFill>
+                      <a:prstDash val="solid"/>
+                      <a:round/>
+                      <a:headEnd type="none" w="med" len="med"/>
+                      <a:tailEnd type="none" w="med" len="med"/>
+                    </a:lnL>
+                    <a:lnR w="9525" cap="flat" cmpd="sng" algn="ctr">
+                      <a:solidFill>
+                        <a:srgbClr val="BFC5CF"/>
+                      </a:solidFill>
+                      <a:prstDash val="solid"/>
+                      <a:round/>
+                      <a:headEnd type="none" w="med" len="med"/>
+                      <a:tailEnd type="none" w="med" len="med"/>
+                    </a:lnR>
+                    <a:lnT w="9525" cap="flat" cmpd="sng" algn="ctr">
+                      <a:solidFill>
+                        <a:srgbClr val="BFC5CF"/>
+                      </a:solidFill>
+                      <a:prstDash val="solid"/>
+                      <a:round/>
+                      <a:headEnd type="none" w="med" len="med"/>
+                      <a:tailEnd type="none" w="med" len="med"/>
+                    </a:lnT>
+                    <a:lnB w="9525" cap="flat" cmpd="sng" algn="ctr">
+                      <a:solidFill>
+                        <a:srgbClr val="BFC5CF"/>
+                      </a:solidFill>
+                      <a:prstDash val="solid"/>
+                      <a:round/>
+                      <a:headEnd type="none" w="med" len="med"/>
+                      <a:tailEnd type="none" w="med" len="med"/>
+                    </a:lnB>
+                  </a:tcPr>
+                </a:tc>
+                <a:tc>
+                  <a:txBody>
+                    <a:bodyPr/>
+                    <a:lstStyle/>
+                    <a:p>
+                      <a:pPr indent="0" marL="0">
+                        <a:buNone/>
+                      </a:pPr>
+                      <a:r>
+                        <a:rPr lang="en-US" sz="900" dirty="0">
+                          <a:solidFill>
+                            <a:srgbClr val="1F2329"/>
+                          </a:solidFill>
+                          <a:latin typeface="맑은 고딕" pitchFamily="34" charset="0"/>
+                          <a:ea typeface="맑은 고딕" pitchFamily="34" charset="-122"/>
+                          <a:cs typeface="맑은 고딕" pitchFamily="34" charset="-120"/>
+                        </a:rPr>
+                        <a:t>실행 및 플랫폼</a:t>
+                      </a:r>
+                      <a:endParaRPr lang="en-US" sz="900" dirty="0">
+                        <a:latin typeface="맑은 고딕" charset="0"/>
+                        <a:ea typeface="맑은 고딕" charset="0"/>
+                        <a:cs typeface="맑은 고딕" charset="0"/>
+                      </a:endParaRPr>
+                    </a:p>
+                  </a:txBody>
+                  <a:tcPr marL="45720" marR="45720" marT="18288" marB="18288" anchor="ctr">
+                    <a:lnL w="9525" cap="flat" cmpd="sng" algn="ctr">
+                      <a:solidFill>
+                        <a:srgbClr val="BFC5CF"/>
+                      </a:solidFill>
+                      <a:prstDash val="solid"/>
+                      <a:round/>
+                      <a:headEnd type="none" w="med" len="med"/>
+                      <a:tailEnd type="none" w="med" len="med"/>
+                    </a:lnL>
+                    <a:lnR w="9525" cap="flat" cmpd="sng" algn="ctr">
+                      <a:solidFill>
+                        <a:srgbClr val="BFC5CF"/>
+                      </a:solidFill>
+                      <a:prstDash val="solid"/>
+                      <a:round/>
+                      <a:headEnd type="none" w="med" len="med"/>
+                      <a:tailEnd type="none" w="med" len="med"/>
+                    </a:lnR>
+                    <a:lnT w="9525" cap="flat" cmpd="sng" algn="ctr">
+                      <a:solidFill>
+                        <a:srgbClr val="BFC5CF"/>
+                      </a:solidFill>
+                      <a:prstDash val="solid"/>
+                      <a:round/>
+                      <a:headEnd type="none" w="med" len="med"/>
+                      <a:tailEnd type="none" w="med" len="med"/>
+                    </a:lnT>
+                    <a:lnB w="9525" cap="flat" cmpd="sng" algn="ctr">
+                      <a:solidFill>
+                        <a:srgbClr val="BFC5CF"/>
+                      </a:solidFill>
+                      <a:prstDash val="solid"/>
+                      <a:round/>
+                      <a:headEnd type="none" w="med" len="med"/>
+                      <a:tailEnd type="none" w="med" len="med"/>
+                    </a:lnB>
+                  </a:tcPr>
+                </a:tc>
+                <a:tc>
+                  <a:txBody>
+                    <a:bodyPr/>
+                    <a:lstStyle/>
+                    <a:p>
+                      <a:pPr indent="0" marL="0">
+                        <a:buNone/>
+                      </a:pPr>
+                      <a:r>
+                        <a:rPr lang="en-US" sz="900" b="1" dirty="0">
+                          <a:solidFill>
+                            <a:srgbClr val="D0342C"/>
+                          </a:solidFill>
+                          <a:latin typeface="맑은 고딕" pitchFamily="34" charset="0"/>
+                          <a:ea typeface="맑은 고딕" pitchFamily="34" charset="-122"/>
+                          <a:cs typeface="맑은 고딕" pitchFamily="34" charset="-120"/>
+                        </a:rPr>
+                        <a:t>AI혁신센터 · D&amp;AX부문 (엔지니어)</a:t>
+                      </a:r>
+                      <a:endParaRPr lang="en-US" sz="900" dirty="0">
+                        <a:latin typeface="맑은 고딕" charset="0"/>
+                        <a:ea typeface="맑은 고딕" charset="0"/>
+                        <a:cs typeface="맑은 고딕" charset="0"/>
+                      </a:endParaRPr>
+                    </a:p>
+                  </a:txBody>
+                  <a:tcPr marL="45720" marR="45720" marT="18288" marB="18288" anchor="ctr">
+                    <a:lnL w="9525" cap="flat" cmpd="sng" algn="ctr">
+                      <a:solidFill>
+                        <a:srgbClr val="BFC5CF"/>
+                      </a:solidFill>
+                      <a:prstDash val="solid"/>
+                      <a:round/>
+                      <a:headEnd type="none" w="med" len="med"/>
+                      <a:tailEnd type="none" w="med" len="med"/>
+                    </a:lnL>
+                    <a:lnR w="9525" cap="flat" cmpd="sng" algn="ctr">
+                      <a:solidFill>
+                        <a:srgbClr val="BFC5CF"/>
+                      </a:solidFill>
+                      <a:prstDash val="solid"/>
+                      <a:round/>
+                      <a:headEnd type="none" w="med" len="med"/>
+                      <a:tailEnd type="none" w="med" len="med"/>
+                    </a:lnR>
+                    <a:lnT w="9525" cap="flat" cmpd="sng" algn="ctr">
+                      <a:solidFill>
+                        <a:srgbClr val="BFC5CF"/>
+                      </a:solidFill>
+                      <a:prstDash val="solid"/>
+                      <a:round/>
+                      <a:headEnd type="none" w="med" len="med"/>
+                      <a:tailEnd type="none" w="med" len="med"/>
+                    </a:lnT>
+                    <a:lnB w="9525" cap="flat" cmpd="sng" algn="ctr">
+                      <a:solidFill>
+                        <a:srgbClr val="BFC5CF"/>
+                      </a:solidFill>
+                      <a:prstDash val="solid"/>
+                      <a:round/>
+                      <a:headEnd type="none" w="med" len="med"/>
+                      <a:tailEnd type="none" w="med" len="med"/>
+                    </a:lnB>
+                  </a:tcPr>
+                </a:tc>
+              </a:tr>
+              <a:tr h="237744">
+                <a:tc>
+                  <a:txBody>
+                    <a:bodyPr/>
+                    <a:lstStyle/>
+                    <a:p>
+                      <a:pPr algn="ctr" indent="0" marL="0">
+                        <a:buNone/>
+                      </a:pPr>
+                      <a:r>
+                        <a:rPr lang="en-US" sz="900" b="1" dirty="0">
+                          <a:solidFill>
+                            <a:srgbClr val="1F2329"/>
+                          </a:solidFill>
+                          <a:latin typeface="맑은 고딕" pitchFamily="34" charset="0"/>
+                          <a:ea typeface="맑은 고딕" pitchFamily="34" charset="-122"/>
+                          <a:cs typeface="맑은 고딕" pitchFamily="34" charset="-120"/>
+                        </a:rPr>
+                        <a:t>McKinsey·BCG식</a:t>
+                      </a:r>
+                      <a:endParaRPr lang="en-US" sz="900" dirty="0">
+                        <a:latin typeface="맑은 고딕" charset="0"/>
+                        <a:ea typeface="맑은 고딕" charset="0"/>
+                        <a:cs typeface="맑은 고딕" charset="0"/>
+                      </a:endParaRPr>
+                    </a:p>
+                  </a:txBody>
+                  <a:tcPr marL="45720" marR="45720" marT="18288" marB="18288" anchor="ctr">
+                    <a:lnL w="9525" cap="flat" cmpd="sng" algn="ctr">
+                      <a:solidFill>
+                        <a:srgbClr val="BFC5CF"/>
+                      </a:solidFill>
+                      <a:prstDash val="solid"/>
+                      <a:round/>
+                      <a:headEnd type="none" w="med" len="med"/>
+                      <a:tailEnd type="none" w="med" len="med"/>
+                    </a:lnL>
+                    <a:lnR w="9525" cap="flat" cmpd="sng" algn="ctr">
+                      <a:solidFill>
+                        <a:srgbClr val="BFC5CF"/>
+                      </a:solidFill>
+                      <a:prstDash val="solid"/>
+                      <a:round/>
+                      <a:headEnd type="none" w="med" len="med"/>
+                      <a:tailEnd type="none" w="med" len="med"/>
+                    </a:lnR>
+                    <a:lnT w="9525" cap="flat" cmpd="sng" algn="ctr">
+                      <a:solidFill>
+                        <a:srgbClr val="BFC5CF"/>
+                      </a:solidFill>
+                      <a:prstDash val="solid"/>
+                      <a:round/>
+                      <a:headEnd type="none" w="med" len="med"/>
+                      <a:tailEnd type="none" w="med" len="med"/>
+                    </a:lnT>
+                    <a:lnB w="9525" cap="flat" cmpd="sng" algn="ctr">
+                      <a:solidFill>
+                        <a:srgbClr val="BFC5CF"/>
+                      </a:solidFill>
+                      <a:prstDash val="solid"/>
+                      <a:round/>
+                      <a:headEnd type="none" w="med" len="med"/>
+                      <a:tailEnd type="none" w="med" len="med"/>
+                    </a:lnB>
+                  </a:tcPr>
+                </a:tc>
+                <a:tc>
+                  <a:txBody>
+                    <a:bodyPr/>
+                    <a:lstStyle/>
+                    <a:p>
+                      <a:pPr indent="0" marL="0">
+                        <a:buNone/>
+                      </a:pPr>
+                      <a:r>
+                        <a:rPr lang="en-US" sz="900" dirty="0">
+                          <a:solidFill>
+                            <a:srgbClr val="1F2329"/>
+                          </a:solidFill>
+                          <a:latin typeface="맑은 고딕" pitchFamily="34" charset="0"/>
+                          <a:ea typeface="맑은 고딕" pitchFamily="34" charset="-122"/>
+                          <a:cs typeface="맑은 고딕" pitchFamily="34" charset="-120"/>
+                        </a:rPr>
+                        <a:t>경영·조직 재설계</a:t>
+                      </a:r>
+                      <a:endParaRPr lang="en-US" sz="900" dirty="0">
+                        <a:latin typeface="맑은 고딕" charset="0"/>
+                        <a:ea typeface="맑은 고딕" charset="0"/>
+                        <a:cs typeface="맑은 고딕" charset="0"/>
+                      </a:endParaRPr>
+                    </a:p>
+                  </a:txBody>
+                  <a:tcPr marL="45720" marR="45720" marT="18288" marB="18288" anchor="ctr">
+                    <a:lnL w="9525" cap="flat" cmpd="sng" algn="ctr">
+                      <a:solidFill>
+                        <a:srgbClr val="BFC5CF"/>
+                      </a:solidFill>
+                      <a:prstDash val="solid"/>
+                      <a:round/>
+                      <a:headEnd type="none" w="med" len="med"/>
+                      <a:tailEnd type="none" w="med" len="med"/>
+                    </a:lnL>
+                    <a:lnR w="9525" cap="flat" cmpd="sng" algn="ctr">
+                      <a:solidFill>
+                        <a:srgbClr val="BFC5CF"/>
+                      </a:solidFill>
+                      <a:prstDash val="solid"/>
+                      <a:round/>
+                      <a:headEnd type="none" w="med" len="med"/>
+                      <a:tailEnd type="none" w="med" len="med"/>
+                    </a:lnR>
+                    <a:lnT w="9525" cap="flat" cmpd="sng" algn="ctr">
+                      <a:solidFill>
+                        <a:srgbClr val="BFC5CF"/>
+                      </a:solidFill>
+                      <a:prstDash val="solid"/>
+                      <a:round/>
+                      <a:headEnd type="none" w="med" len="med"/>
+                      <a:tailEnd type="none" w="med" len="med"/>
+                    </a:lnT>
+                    <a:lnB w="9525" cap="flat" cmpd="sng" algn="ctr">
+                      <a:solidFill>
+                        <a:srgbClr val="BFC5CF"/>
+                      </a:solidFill>
+                      <a:prstDash val="solid"/>
+                      <a:round/>
+                      <a:headEnd type="none" w="med" len="med"/>
+                      <a:tailEnd type="none" w="med" len="med"/>
+                    </a:lnB>
+                  </a:tcPr>
+                </a:tc>
+                <a:tc>
+                  <a:txBody>
+                    <a:bodyPr/>
+                    <a:lstStyle/>
+                    <a:p>
+                      <a:pPr indent="0" marL="0">
+                        <a:buNone/>
+                      </a:pPr>
+                      <a:r>
+                        <a:rPr lang="en-US" sz="900" b="1" dirty="0">
+                          <a:solidFill>
+                            <a:srgbClr val="0F7B6C"/>
+                          </a:solidFill>
+                          <a:latin typeface="맑은 고딕" pitchFamily="34" charset="0"/>
+                          <a:ea typeface="맑은 고딕" pitchFamily="34" charset="-122"/>
+                          <a:cs typeface="맑은 고딕" pitchFamily="34" charset="-120"/>
+                        </a:rPr>
+                        <a:t>Biz컨설팅팀 (차세대 PI/ISP, 도메인)</a:t>
+                      </a:r>
+                      <a:endParaRPr lang="en-US" sz="900" dirty="0">
+                        <a:latin typeface="맑은 고딕" charset="0"/>
+                        <a:ea typeface="맑은 고딕" charset="0"/>
+                        <a:cs typeface="맑은 고딕" charset="0"/>
+                      </a:endParaRPr>
+                    </a:p>
+                  </a:txBody>
+                  <a:tcPr marL="45720" marR="45720" marT="18288" marB="18288" anchor="ctr">
+                    <a:lnL w="9525" cap="flat" cmpd="sng" algn="ctr">
+                      <a:solidFill>
+                        <a:srgbClr val="BFC5CF"/>
+                      </a:solidFill>
+                      <a:prstDash val="solid"/>
+                      <a:round/>
+                      <a:headEnd type="none" w="med" len="med"/>
+                      <a:tailEnd type="none" w="med" len="med"/>
+                    </a:lnL>
+                    <a:lnR w="9525" cap="flat" cmpd="sng" algn="ctr">
+                      <a:solidFill>
+                        <a:srgbClr val="BFC5CF"/>
+                      </a:solidFill>
+                      <a:prstDash val="solid"/>
+                      <a:round/>
+                      <a:headEnd type="none" w="med" len="med"/>
+                      <a:tailEnd type="none" w="med" len="med"/>
+                    </a:lnR>
+                    <a:lnT w="9525" cap="flat" cmpd="sng" algn="ctr">
+                      <a:solidFill>
+                        <a:srgbClr val="BFC5CF"/>
+                      </a:solidFill>
+                      <a:prstDash val="solid"/>
+                      <a:round/>
+                      <a:headEnd type="none" w="med" len="med"/>
+                      <a:tailEnd type="none" w="med" len="med"/>
+                    </a:lnT>
+                    <a:lnB w="9525" cap="flat" cmpd="sng" algn="ctr">
+                      <a:solidFill>
+                        <a:srgbClr val="BFC5CF"/>
+                      </a:solidFill>
+                      <a:prstDash val="solid"/>
+                      <a:round/>
+                      <a:headEnd type="none" w="med" len="med"/>
+                      <a:tailEnd type="none" w="med" len="med"/>
+                    </a:lnB>
+                  </a:tcPr>
+                </a:tc>
+              </a:tr>
+              <a:tr h="237744">
+                <a:tc>
+                  <a:txBody>
+                    <a:bodyPr/>
+                    <a:lstStyle/>
+                    <a:p>
+                      <a:pPr algn="ctr" indent="0" marL="0">
+                        <a:buNone/>
+                      </a:pPr>
+                      <a:r>
+                        <a:rPr lang="en-US" sz="900" b="1" dirty="0">
+                          <a:solidFill>
+                            <a:srgbClr val="1F2329"/>
+                          </a:solidFill>
+                          <a:latin typeface="맑은 고딕" pitchFamily="34" charset="0"/>
+                          <a:ea typeface="맑은 고딕" pitchFamily="34" charset="-122"/>
+                          <a:cs typeface="맑은 고딕" pitchFamily="34" charset="-120"/>
+                        </a:rPr>
+                        <a:t>Big Four식</a:t>
+                      </a:r>
+                      <a:endParaRPr lang="en-US" sz="900" dirty="0">
+                        <a:latin typeface="맑은 고딕" charset="0"/>
+                        <a:ea typeface="맑은 고딕" charset="0"/>
+                        <a:cs typeface="맑은 고딕" charset="0"/>
+                      </a:endParaRPr>
+                    </a:p>
+                  </a:txBody>
+                  <a:tcPr marL="45720" marR="45720" marT="18288" marB="18288" anchor="ctr">
+                    <a:lnL w="9525" cap="flat" cmpd="sng" algn="ctr">
+                      <a:solidFill>
+                        <a:srgbClr val="BFC5CF"/>
+                      </a:solidFill>
+                      <a:prstDash val="solid"/>
+                      <a:round/>
+                      <a:headEnd type="none" w="med" len="med"/>
+                      <a:tailEnd type="none" w="med" len="med"/>
+                    </a:lnL>
+                    <a:lnR w="9525" cap="flat" cmpd="sng" algn="ctr">
+                      <a:solidFill>
+                        <a:srgbClr val="BFC5CF"/>
+                      </a:solidFill>
+                      <a:prstDash val="solid"/>
+                      <a:round/>
+                      <a:headEnd type="none" w="med" len="med"/>
+                      <a:tailEnd type="none" w="med" len="med"/>
+                    </a:lnR>
+                    <a:lnT w="9525" cap="flat" cmpd="sng" algn="ctr">
+                      <a:solidFill>
+                        <a:srgbClr val="BFC5CF"/>
+                      </a:solidFill>
+                      <a:prstDash val="solid"/>
+                      <a:round/>
+                      <a:headEnd type="none" w="med" len="med"/>
+                      <a:tailEnd type="none" w="med" len="med"/>
+                    </a:lnT>
+                    <a:lnB w="9525" cap="flat" cmpd="sng" algn="ctr">
+                      <a:solidFill>
+                        <a:srgbClr val="BFC5CF"/>
+                      </a:solidFill>
+                      <a:prstDash val="solid"/>
+                      <a:round/>
+                      <a:headEnd type="none" w="med" len="med"/>
+                      <a:tailEnd type="none" w="med" len="med"/>
+                    </a:lnB>
+                  </a:tcPr>
+                </a:tc>
+                <a:tc>
+                  <a:txBody>
+                    <a:bodyPr/>
+                    <a:lstStyle/>
+                    <a:p>
+                      <a:pPr indent="0" marL="0">
+                        <a:buNone/>
+                      </a:pPr>
+                      <a:r>
+                        <a:rPr lang="en-US" sz="900" dirty="0">
+                          <a:solidFill>
+                            <a:srgbClr val="1F2329"/>
+                          </a:solidFill>
+                          <a:latin typeface="맑은 고딕" pitchFamily="34" charset="0"/>
+                          <a:ea typeface="맑은 고딕" pitchFamily="34" charset="-122"/>
+                          <a:cs typeface="맑은 고딕" pitchFamily="34" charset="-120"/>
+                        </a:rPr>
+                        <a:t>리스크·규제 통제</a:t>
+                      </a:r>
+                      <a:endParaRPr lang="en-US" sz="900" dirty="0">
+                        <a:latin typeface="맑은 고딕" charset="0"/>
+                        <a:ea typeface="맑은 고딕" charset="0"/>
+                        <a:cs typeface="맑은 고딕" charset="0"/>
+                      </a:endParaRPr>
+                    </a:p>
+                  </a:txBody>
+                  <a:tcPr marL="45720" marR="45720" marT="18288" marB="18288" anchor="ctr">
+                    <a:lnL w="9525" cap="flat" cmpd="sng" algn="ctr">
+                      <a:solidFill>
+                        <a:srgbClr val="BFC5CF"/>
+                      </a:solidFill>
+                      <a:prstDash val="solid"/>
+                      <a:round/>
+                      <a:headEnd type="none" w="med" len="med"/>
+                      <a:tailEnd type="none" w="med" len="med"/>
+                    </a:lnL>
+                    <a:lnR w="9525" cap="flat" cmpd="sng" algn="ctr">
+                      <a:solidFill>
+                        <a:srgbClr val="BFC5CF"/>
+                      </a:solidFill>
+                      <a:prstDash val="solid"/>
+                      <a:round/>
+                      <a:headEnd type="none" w="med" len="med"/>
+                      <a:tailEnd type="none" w="med" len="med"/>
+                    </a:lnR>
+                    <a:lnT w="9525" cap="flat" cmpd="sng" algn="ctr">
+                      <a:solidFill>
+                        <a:srgbClr val="BFC5CF"/>
+                      </a:solidFill>
+                      <a:prstDash val="solid"/>
+                      <a:round/>
+                      <a:headEnd type="none" w="med" len="med"/>
+                      <a:tailEnd type="none" w="med" len="med"/>
+                    </a:lnT>
+                    <a:lnB w="9525" cap="flat" cmpd="sng" algn="ctr">
+                      <a:solidFill>
+                        <a:srgbClr val="BFC5CF"/>
+                      </a:solidFill>
+                      <a:prstDash val="solid"/>
+                      <a:round/>
+                      <a:headEnd type="none" w="med" len="med"/>
+                      <a:tailEnd type="none" w="med" len="med"/>
+                    </a:lnB>
+                  </a:tcPr>
+                </a:tc>
+                <a:tc>
+                  <a:txBody>
+                    <a:bodyPr/>
+                    <a:lstStyle/>
+                    <a:p>
+                      <a:pPr indent="0" marL="0">
+                        <a:buNone/>
+                      </a:pPr>
+                      <a:r>
+                        <a:rPr lang="en-US" sz="900" b="1" dirty="0">
+                          <a:solidFill>
+                            <a:srgbClr val="1F4E9A"/>
+                          </a:solidFill>
+                          <a:latin typeface="맑은 고딕" pitchFamily="34" charset="0"/>
+                          <a:ea typeface="맑은 고딕" pitchFamily="34" charset="-122"/>
+                          <a:cs typeface="맑은 고딕" pitchFamily="34" charset="-120"/>
+                        </a:rPr>
+                        <a:t>AX컨설팅팀 AI 거버넌스·성과관리 + 그룹 정보보안</a:t>
+                      </a:r>
+                      <a:endParaRPr lang="en-US" sz="900" dirty="0">
+                        <a:latin typeface="맑은 고딕" charset="0"/>
+                        <a:ea typeface="맑은 고딕" charset="0"/>
+                        <a:cs typeface="맑은 고딕" charset="0"/>
+                      </a:endParaRPr>
+                    </a:p>
+                  </a:txBody>
+                  <a:tcPr marL="45720" marR="45720" marT="18288" marB="18288" anchor="ctr">
+                    <a:lnL w="9525" cap="flat" cmpd="sng" algn="ctr">
+                      <a:solidFill>
+                        <a:srgbClr val="BFC5CF"/>
+                      </a:solidFill>
+                      <a:prstDash val="solid"/>
+                      <a:round/>
+                      <a:headEnd type="none" w="med" len="med"/>
+                      <a:tailEnd type="none" w="med" len="med"/>
+                    </a:lnL>
+                    <a:lnR w="9525" cap="flat" cmpd="sng" algn="ctr">
+                      <a:solidFill>
+                        <a:srgbClr val="BFC5CF"/>
+                      </a:solidFill>
+                      <a:prstDash val="solid"/>
+                      <a:round/>
+                      <a:headEnd type="none" w="med" len="med"/>
+                      <a:tailEnd type="none" w="med" len="med"/>
+                    </a:lnR>
+                    <a:lnT w="9525" cap="flat" cmpd="sng" algn="ctr">
+                      <a:solidFill>
+                        <a:srgbClr val="BFC5CF"/>
+                      </a:solidFill>
+                      <a:prstDash val="solid"/>
+                      <a:round/>
+                      <a:headEnd type="none" w="med" len="med"/>
+                      <a:tailEnd type="none" w="med" len="med"/>
+                    </a:lnT>
+                    <a:lnB w="9525" cap="flat" cmpd="sng" algn="ctr">
+                      <a:solidFill>
+                        <a:srgbClr val="BFC5CF"/>
+                      </a:solidFill>
+                      <a:prstDash val="solid"/>
+                      <a:round/>
+                      <a:headEnd type="none" w="med" len="med"/>
+                      <a:tailEnd type="none" w="med" len="med"/>
+                    </a:lnB>
+                  </a:tcPr>
+                </a:tc>
+              </a:tr>
+            </a:tbl>
+          </a:graphicData>
+        </a:graphic>
+      </p:graphicFrame>
+      <p:sp>
+        <p:nvSpPr>
+          <p:cNvPr id="29" name="결론"/>
+          <p:cNvSpPr txBox="1"/>
+          <p:nvPr/>
+        </p:nvSpPr>
+        <p:spPr>
+          <a:xfrm>
+            <a:off x="6291072" y="5733288"/>
+            <a:ext cx="5532120" cy="621792"/>
+          </a:xfrm>
+          <a:prstGeom prst="rect">
+            <a:avLst/>
+          </a:prstGeom>
+          <a:solidFill>
+            <a:schemeClr val="tx2"/>
+          </a:solidFill>
+          <a:ln/>
+        </p:spPr>
+        <p:txBody>
+          <a:bodyPr wrap="square" lIns="0" tIns="101600" rIns="101600" bIns="0" rtlCol="0" anchor="ctr"/>
+          <a:lstStyle/>
+          <a:p>
+            <a:pPr algn="ctr" indent="0" marL="0">
+              <a:buNone/>
+            </a:pPr>
+            <a:r>
+              <a:rPr lang="en-US" sz="1100" b="1" dirty="0">
+                <a:solidFill>
+                  <a:schemeClr val="bg1"/>
+                </a:solidFill>
+              </a:rPr>
+              <a:t>세 역량이 모두 그룹 내부에 존재 → FDE 공동 TF로 결합하면 외부 컨설팅사 혼합모델을 내재화하여 수행 가능</a:t>
+            </a:r>
+            <a:endParaRPr lang="en-US" sz="1100" dirty="0"/>
+          </a:p>
+        </p:txBody>
+      </p:sp>
+    </p:spTree>
+  </p:cSld>
+  <p:clrMapOvr>
+    <a:masterClrMapping/>
+  </p:clrMapOvr>
+</p:sld>
+</file>
+
 <file path=ppt/theme/theme1.xml><?xml version="1.0" encoding="utf-8"?>
 <a:theme xmlns:a="http://schemas.openxmlformats.org/drawingml/2006/main" name="AX Consulting">
   <a:themeElements>

</xml_diff>